<commit_message>
Updated the Viva Presentation
</commit_message>
<xml_diff>
--- a/doc/milestone_03/MiguelAbela_SWD63A_RD2_VIVA.pptx
+++ b/doc/milestone_03/MiguelAbela_SWD63A_RD2_VIVA.pptx
@@ -5,7 +5,7 @@
     <p:sldMasterId id="2147483659" r:id="rId4"/>
   </p:sldMasterIdLst>
   <p:notesMasterIdLst>
-    <p:notesMasterId r:id="rId15"/>
+    <p:notesMasterId r:id="rId16"/>
   </p:notesMasterIdLst>
   <p:sldIdLst>
     <p:sldId id="256" r:id="rId5"/>
@@ -14,27 +14,28 @@
     <p:sldId id="308" r:id="rId8"/>
     <p:sldId id="309" r:id="rId9"/>
     <p:sldId id="294" r:id="rId10"/>
-    <p:sldId id="310" r:id="rId11"/>
-    <p:sldId id="311" r:id="rId12"/>
-    <p:sldId id="307" r:id="rId13"/>
-    <p:sldId id="271" r:id="rId14"/>
+    <p:sldId id="313" r:id="rId11"/>
+    <p:sldId id="310" r:id="rId12"/>
+    <p:sldId id="311" r:id="rId13"/>
+    <p:sldId id="307" r:id="rId14"/>
+    <p:sldId id="271" r:id="rId15"/>
   </p:sldIdLst>
   <p:sldSz cx="9144000" cy="5143500" type="screen16x9"/>
   <p:notesSz cx="6858000" cy="9144000"/>
   <p:embeddedFontLst>
     <p:embeddedFont>
       <p:font typeface="Lato" panose="020F0502020204030203" pitchFamily="34" charset="0"/>
-      <p:regular r:id="rId16"/>
-      <p:bold r:id="rId17"/>
-      <p:italic r:id="rId18"/>
-      <p:boldItalic r:id="rId19"/>
+      <p:regular r:id="rId17"/>
+      <p:bold r:id="rId18"/>
+      <p:italic r:id="rId19"/>
+      <p:boldItalic r:id="rId20"/>
     </p:embeddedFont>
     <p:embeddedFont>
       <p:font typeface="Raleway" pitchFamily="2" charset="0"/>
-      <p:regular r:id="rId20"/>
-      <p:bold r:id="rId21"/>
-      <p:italic r:id="rId22"/>
-      <p:boldItalic r:id="rId23"/>
+      <p:regular r:id="rId21"/>
+      <p:bold r:id="rId22"/>
+      <p:italic r:id="rId23"/>
+      <p:boldItalic r:id="rId24"/>
     </p:embeddedFont>
   </p:embeddedFontLst>
   <p:defaultTextStyle>
@@ -873,11 +874,201 @@
               </a:spcAft>
               <a:buNone/>
             </a:pPr>
+            <a:r>
+              <a:rPr lang="en-US" dirty="0"/>
+              <a:t>Good morning, today I will be presenting my research on Tree-Based Machine Learning Regression Models for Predicting Marathon Race Times.</a:t>
+            </a:r>
             <a:endParaRPr dirty="0"/>
           </a:p>
         </p:txBody>
       </p:sp>
     </p:spTree>
+  </p:cSld>
+  <p:clrMapOvr>
+    <a:masterClrMapping/>
+  </p:clrMapOvr>
+</p:notes>
+</file>
+
+<file path=ppt/notesSlides/notesSlide10.xml><?xml version="1.0" encoding="utf-8"?>
+<p:notes xmlns:a="http://schemas.openxmlformats.org/drawingml/2006/main" xmlns:r="http://schemas.openxmlformats.org/officeDocument/2006/relationships" xmlns:p="http://schemas.openxmlformats.org/presentationml/2006/main" showMasterSp="0" showMasterPhAnim="0">
+  <p:cSld>
+    <p:spTree>
+      <p:nvGrpSpPr>
+        <p:cNvPr id="1" name="Shape 56"/>
+        <p:cNvGrpSpPr/>
+        <p:nvPr/>
+      </p:nvGrpSpPr>
+      <p:grpSpPr>
+        <a:xfrm>
+          <a:off x="0" y="0"/>
+          <a:ext cx="0" cy="0"/>
+          <a:chOff x="0" y="0"/>
+          <a:chExt cx="0" cy="0"/>
+        </a:xfrm>
+      </p:grpSpPr>
+      <p:sp>
+        <p:nvSpPr>
+          <p:cNvPr id="57" name="Shape 57"/>
+          <p:cNvSpPr>
+            <a:spLocks noGrp="1" noRot="1" noChangeAspect="1"/>
+          </p:cNvSpPr>
+          <p:nvPr>
+            <p:ph type="sldImg" idx="2"/>
+          </p:nvPr>
+        </p:nvSpPr>
+        <p:spPr>
+          <a:xfrm>
+            <a:off x="381000" y="685800"/>
+            <a:ext cx="6096000" cy="3429000"/>
+          </a:xfrm>
+          <a:custGeom>
+            <a:avLst/>
+            <a:gdLst/>
+            <a:ahLst/>
+            <a:cxnLst/>
+            <a:rect l="0" t="0" r="0" b="0"/>
+            <a:pathLst>
+              <a:path w="120000" h="120000" extrusionOk="0">
+                <a:moveTo>
+                  <a:pt x="0" y="0"/>
+                </a:moveTo>
+                <a:lnTo>
+                  <a:pt x="120000" y="0"/>
+                </a:lnTo>
+                <a:lnTo>
+                  <a:pt x="120000" y="120000"/>
+                </a:lnTo>
+                <a:lnTo>
+                  <a:pt x="0" y="120000"/>
+                </a:lnTo>
+                <a:close/>
+              </a:path>
+            </a:pathLst>
+          </a:custGeom>
+        </p:spPr>
+      </p:sp>
+      <p:sp>
+        <p:nvSpPr>
+          <p:cNvPr id="58" name="Shape 58"/>
+          <p:cNvSpPr txBox="1">
+            <a:spLocks noGrp="1"/>
+          </p:cNvSpPr>
+          <p:nvPr>
+            <p:ph type="body" idx="1"/>
+          </p:nvPr>
+        </p:nvSpPr>
+        <p:spPr>
+          <a:xfrm>
+            <a:off x="685800" y="4343400"/>
+            <a:ext cx="5486400" cy="4114800"/>
+          </a:xfrm>
+          <a:prstGeom prst="rect">
+            <a:avLst/>
+          </a:prstGeom>
+        </p:spPr>
+        <p:txBody>
+          <a:bodyPr spcFirstLastPara="1" wrap="square" lIns="91425" tIns="91425" rIns="91425" bIns="91425" anchor="t" anchorCtr="0">
+            <a:noAutofit/>
+          </a:bodyPr>
+          <a:lstStyle/>
+          <a:p>
+            <a:pPr marL="0" lvl="0" indent="0">
+              <a:spcBef>
+                <a:spcPts val="0"/>
+              </a:spcBef>
+              <a:spcAft>
+                <a:spcPts val="0"/>
+              </a:spcAft>
+              <a:buNone/>
+            </a:pPr>
+            <a:r>
+              <a:rPr lang="en-US" dirty="0"/>
+              <a:t>These were the references used within this presentation.</a:t>
+            </a:r>
+            <a:endParaRPr dirty="0"/>
+          </a:p>
+        </p:txBody>
+      </p:sp>
+    </p:spTree>
+    <p:extLst>
+      <p:ext uri="{BB962C8B-B14F-4D97-AF65-F5344CB8AC3E}">
+        <p14:creationId xmlns:p14="http://schemas.microsoft.com/office/powerpoint/2010/main" val="3294784187"/>
+      </p:ext>
+    </p:extLst>
+  </p:cSld>
+  <p:clrMapOvr>
+    <a:masterClrMapping/>
+  </p:clrMapOvr>
+</p:notes>
+</file>
+
+<file path=ppt/notesSlides/notesSlide11.xml><?xml version="1.0" encoding="utf-8"?>
+<p:notes xmlns:a="http://schemas.openxmlformats.org/drawingml/2006/main" xmlns:r="http://schemas.openxmlformats.org/officeDocument/2006/relationships" xmlns:p="http://schemas.openxmlformats.org/presentationml/2006/main">
+  <p:cSld>
+    <p:spTree>
+      <p:nvGrpSpPr>
+        <p:cNvPr id="1" name=""/>
+        <p:cNvGrpSpPr/>
+        <p:nvPr/>
+      </p:nvGrpSpPr>
+      <p:grpSpPr>
+        <a:xfrm>
+          <a:off x="0" y="0"/>
+          <a:ext cx="0" cy="0"/>
+          <a:chOff x="0" y="0"/>
+          <a:chExt cx="0" cy="0"/>
+        </a:xfrm>
+      </p:grpSpPr>
+      <p:sp>
+        <p:nvSpPr>
+          <p:cNvPr id="2" name="Slide Image Placeholder 1"/>
+          <p:cNvSpPr>
+            <a:spLocks noGrp="1" noRot="1" noChangeAspect="1"/>
+          </p:cNvSpPr>
+          <p:nvPr>
+            <p:ph type="sldImg"/>
+          </p:nvPr>
+        </p:nvSpPr>
+        <p:spPr>
+          <a:xfrm>
+            <a:off x="381000" y="685800"/>
+            <a:ext cx="6096000" cy="3429000"/>
+          </a:xfrm>
+        </p:spPr>
+      </p:sp>
+      <p:sp>
+        <p:nvSpPr>
+          <p:cNvPr id="3" name="Notes Placeholder 2"/>
+          <p:cNvSpPr>
+            <a:spLocks noGrp="1"/>
+          </p:cNvSpPr>
+          <p:nvPr>
+            <p:ph type="body" idx="1"/>
+          </p:nvPr>
+        </p:nvSpPr>
+        <p:spPr/>
+        <p:txBody>
+          <a:bodyPr/>
+          <a:lstStyle/>
+          <a:p>
+            <a:pPr marL="158750" indent="0">
+              <a:buNone/>
+            </a:pPr>
+            <a:r>
+              <a:rPr lang="en-US" dirty="0"/>
+              <a:t>Thank you</a:t>
+            </a:r>
+            <a:endParaRPr lang="en-MT" dirty="0"/>
+          </a:p>
+        </p:txBody>
+      </p:sp>
+    </p:spTree>
+    <p:extLst>
+      <p:ext uri="{BB962C8B-B14F-4D97-AF65-F5344CB8AC3E}">
+        <p14:creationId xmlns:p14="http://schemas.microsoft.com/office/powerpoint/2010/main" val="1328220676"/>
+      </p:ext>
+    </p:extLst>
   </p:cSld>
   <p:clrMapOvr>
     <a:masterClrMapping/>
@@ -981,7 +1172,7 @@
                 <a:cs typeface="Arial"/>
                 <a:sym typeface="Arial"/>
               </a:rPr>
-              <a:t>In recent years, marathon running has increased in popularity, making technology and predictive algorithms staples of training and race day. Yet, such algorithms remain highly challenging to develop.</a:t>
+              <a:t>In recent years, marathon running has increased in popularity, making technology and predictive algorithms a staple within the sport, yet such algorithms remain highly challenging to develop.</a:t>
             </a:r>
           </a:p>
           <a:p>
@@ -1004,7 +1195,7 @@
             </a:pPr>
             <a:r>
               <a:rPr lang="en-US" b="0" dirty="0"/>
-              <a:t>This led to an experimental study in which it is hypothesized that XGBoost will achieve better predictive performance than Random Forest, specifically when using 16 weeks of aggregated training data. To address this hypothesis, the following research questions were formulated to establish a superior model by assessing the effects of time frame-reduced datasets.</a:t>
+              <a:t>This led to this study in which it is hypothesized that XGBoost will achieve better predictive performance than Random Forest, specifically when using 16 weeks of aggregated training data. To address this hypothesis, the following research questions were formulated, establishing a superior model by assessing the effects of time frame-reduced datasets.</a:t>
             </a:r>
             <a:endParaRPr b="0" dirty="0"/>
           </a:p>
@@ -1230,7 +1421,7 @@
             </a:pPr>
             <a:r>
               <a:rPr lang="en-US" dirty="0"/>
-              <a:t>Subsequently, a research pipeline was developed to create multiple datasets with additional derived features.</a:t>
+              <a:t>Subsequently, a research pipeline was developed to create multiple datasets.</a:t>
             </a:r>
             <a:endParaRPr dirty="0"/>
           </a:p>
@@ -1359,7 +1550,91 @@
               </a:spcAft>
               <a:buNone/>
             </a:pPr>
-            <a:endParaRPr dirty="0"/>
+            <a:r>
+              <a:rPr lang="en-US" dirty="0"/>
+              <a:t>Moving on to the methodology, a sequentially ordered dataset comprising daily running activities was initially acquired.</a:t>
+            </a:r>
+          </a:p>
+          <a:p>
+            <a:pPr marL="0" lvl="0" indent="0">
+              <a:spcBef>
+                <a:spcPts val="0"/>
+              </a:spcBef>
+              <a:spcAft>
+                <a:spcPts val="0"/>
+              </a:spcAft>
+              <a:buNone/>
+            </a:pPr>
+            <a:endParaRPr lang="en-US" dirty="0"/>
+          </a:p>
+          <a:p>
+            <a:pPr marL="0" lvl="0" indent="0">
+              <a:spcBef>
+                <a:spcPts val="0"/>
+              </a:spcBef>
+              <a:spcAft>
+                <a:spcPts val="0"/>
+              </a:spcAft>
+              <a:buNone/>
+            </a:pPr>
+            <a:r>
+              <a:rPr lang="en-US" dirty="0"/>
+              <a:t>To achieve this study’s objectives, a filtered dataset emerged, consisting of male runners aged 35 to 54. After viewing other studies, from this demographic-specific data source, six condensed datasets with additional features were developed, starting from 16 weeks until reaching 6 weeks in 2-week intervals. Every athlete’s data was thus aggregated to match model requirements.</a:t>
+            </a:r>
+          </a:p>
+          <a:p>
+            <a:pPr marL="0" lvl="0" indent="0">
+              <a:spcBef>
+                <a:spcPts val="0"/>
+              </a:spcBef>
+              <a:spcAft>
+                <a:spcPts val="0"/>
+              </a:spcAft>
+              <a:buNone/>
+            </a:pPr>
+            <a:endParaRPr lang="en-US" dirty="0"/>
+          </a:p>
+          <a:p>
+            <a:pPr marL="0" lvl="0" indent="0">
+              <a:spcBef>
+                <a:spcPts val="0"/>
+              </a:spcBef>
+              <a:spcAft>
+                <a:spcPts val="0"/>
+              </a:spcAft>
+              <a:buNone/>
+            </a:pPr>
+            <a:r>
+              <a:rPr lang="en-US" dirty="0"/>
+              <a:t>Using the reference solution, model architectures were established and kept the same throughout the experiments, for an unbiased comparison. As adopted by other studies, the experiments were repeated 3 times using a 10-fold cross-validation technique to mitigate any random errors and validate the results.</a:t>
+            </a:r>
+          </a:p>
+          <a:p>
+            <a:pPr marL="0" lvl="0" indent="0">
+              <a:spcBef>
+                <a:spcPts val="0"/>
+              </a:spcBef>
+              <a:spcAft>
+                <a:spcPts val="0"/>
+              </a:spcAft>
+              <a:buNone/>
+            </a:pPr>
+            <a:endParaRPr lang="en-US" dirty="0"/>
+          </a:p>
+          <a:p>
+            <a:pPr marL="0" lvl="0" indent="0">
+              <a:spcBef>
+                <a:spcPts val="0"/>
+              </a:spcBef>
+              <a:spcAft>
+                <a:spcPts val="0"/>
+              </a:spcAft>
+              <a:buNone/>
+            </a:pPr>
+            <a:r>
+              <a:rPr lang="en-US" dirty="0"/>
+              <a:t>Before conducting these six experiments, benchmark models were created to facilitate evaluation through the Mean Absolute Error, Root Mean Squared Error, and R-squared values. </a:t>
+            </a:r>
           </a:p>
         </p:txBody>
       </p:sp>
@@ -1459,17 +1734,19 @@
           </a:bodyPr>
           <a:lstStyle/>
           <a:p>
-            <a:pPr marL="171450" lvl="0" indent="-171450">
-              <a:spcBef>
-                <a:spcPts val="0"/>
-              </a:spcBef>
-              <a:spcAft>
-                <a:spcPts val="0"/>
-              </a:spcAft>
-              <a:buFont typeface="Arial" panose="020B0604020202020204" pitchFamily="34" charset="0"/>
-              <a:buChar char="•"/>
+            <a:pPr marL="0" lvl="0" indent="0">
+              <a:spcBef>
+                <a:spcPts val="0"/>
+              </a:spcBef>
+              <a:spcAft>
+                <a:spcPts val="0"/>
+              </a:spcAft>
+              <a:buNone/>
             </a:pPr>
-            <a:endParaRPr lang="en-US" b="1" dirty="0"/>
+            <a:r>
+              <a:rPr lang="en-US" b="0" dirty="0"/>
+              <a:t>These were the results obtained by the benchmark models. Notably, the best model was XGBoost, having the predicted average marathon race time off by approximately 21 minutes.</a:t>
+            </a:r>
           </a:p>
         </p:txBody>
       </p:sp>
@@ -1487,6 +1764,217 @@
 </file>
 
 <file path=ppt/notesSlides/notesSlide7.xml><?xml version="1.0" encoding="utf-8"?>
+<p:notes xmlns:a="http://schemas.openxmlformats.org/drawingml/2006/main" xmlns:r="http://schemas.openxmlformats.org/officeDocument/2006/relationships" xmlns:p="http://schemas.openxmlformats.org/presentationml/2006/main" showMasterSp="0" showMasterPhAnim="0">
+  <p:cSld>
+    <p:spTree>
+      <p:nvGrpSpPr>
+        <p:cNvPr id="1" name="Shape 56">
+          <a:extLst>
+            <a:ext uri="{FF2B5EF4-FFF2-40B4-BE49-F238E27FC236}">
+              <a16:creationId xmlns:a16="http://schemas.microsoft.com/office/drawing/2014/main" id="{56A68DDC-B25D-C7D2-0C6C-941AED451193}"/>
+            </a:ext>
+          </a:extLst>
+        </p:cNvPr>
+        <p:cNvGrpSpPr/>
+        <p:nvPr/>
+      </p:nvGrpSpPr>
+      <p:grpSpPr>
+        <a:xfrm>
+          <a:off x="0" y="0"/>
+          <a:ext cx="0" cy="0"/>
+          <a:chOff x="0" y="0"/>
+          <a:chExt cx="0" cy="0"/>
+        </a:xfrm>
+      </p:grpSpPr>
+      <p:sp>
+        <p:nvSpPr>
+          <p:cNvPr id="57" name="Shape 57">
+            <a:extLst>
+              <a:ext uri="{FF2B5EF4-FFF2-40B4-BE49-F238E27FC236}">
+                <a16:creationId xmlns:a16="http://schemas.microsoft.com/office/drawing/2014/main" id="{1EDF6906-D42B-6413-835E-A80A4D333369}"/>
+              </a:ext>
+            </a:extLst>
+          </p:cNvPr>
+          <p:cNvSpPr>
+            <a:spLocks noGrp="1" noRot="1" noChangeAspect="1"/>
+          </p:cNvSpPr>
+          <p:nvPr>
+            <p:ph type="sldImg" idx="2"/>
+          </p:nvPr>
+        </p:nvSpPr>
+        <p:spPr>
+          <a:xfrm>
+            <a:off x="381000" y="685800"/>
+            <a:ext cx="6096000" cy="3429000"/>
+          </a:xfrm>
+          <a:custGeom>
+            <a:avLst/>
+            <a:gdLst/>
+            <a:ahLst/>
+            <a:cxnLst/>
+            <a:rect l="0" t="0" r="0" b="0"/>
+            <a:pathLst>
+              <a:path w="120000" h="120000" extrusionOk="0">
+                <a:moveTo>
+                  <a:pt x="0" y="0"/>
+                </a:moveTo>
+                <a:lnTo>
+                  <a:pt x="120000" y="0"/>
+                </a:lnTo>
+                <a:lnTo>
+                  <a:pt x="120000" y="120000"/>
+                </a:lnTo>
+                <a:lnTo>
+                  <a:pt x="0" y="120000"/>
+                </a:lnTo>
+                <a:close/>
+              </a:path>
+            </a:pathLst>
+          </a:custGeom>
+        </p:spPr>
+      </p:sp>
+      <p:sp>
+        <p:nvSpPr>
+          <p:cNvPr id="58" name="Shape 58">
+            <a:extLst>
+              <a:ext uri="{FF2B5EF4-FFF2-40B4-BE49-F238E27FC236}">
+                <a16:creationId xmlns:a16="http://schemas.microsoft.com/office/drawing/2014/main" id="{4DEDFB0F-077E-6EF8-A6A7-1F4BB73B2526}"/>
+              </a:ext>
+            </a:extLst>
+          </p:cNvPr>
+          <p:cNvSpPr txBox="1">
+            <a:spLocks noGrp="1"/>
+          </p:cNvSpPr>
+          <p:nvPr>
+            <p:ph type="body" idx="1"/>
+          </p:nvPr>
+        </p:nvSpPr>
+        <p:spPr>
+          <a:xfrm>
+            <a:off x="685800" y="4343400"/>
+            <a:ext cx="5486400" cy="4114800"/>
+          </a:xfrm>
+          <a:prstGeom prst="rect">
+            <a:avLst/>
+          </a:prstGeom>
+        </p:spPr>
+        <p:txBody>
+          <a:bodyPr spcFirstLastPara="1" wrap="square" lIns="91425" tIns="91425" rIns="91425" bIns="91425" anchor="t" anchorCtr="0">
+            <a:noAutofit/>
+          </a:bodyPr>
+          <a:lstStyle/>
+          <a:p>
+            <a:pPr marL="0" lvl="0" indent="0">
+              <a:spcBef>
+                <a:spcPts val="0"/>
+              </a:spcBef>
+              <a:spcAft>
+                <a:spcPts val="0"/>
+              </a:spcAft>
+              <a:buNone/>
+            </a:pPr>
+            <a:r>
+              <a:rPr lang="en-US" b="0" dirty="0"/>
+              <a:t>On the other hand, when having a controlled environment, with aligned training block data, and a repeated k-fold cross-validation technique, the results show otherwise.</a:t>
+            </a:r>
+          </a:p>
+          <a:p>
+            <a:pPr marL="0" lvl="0" indent="0">
+              <a:spcBef>
+                <a:spcPts val="0"/>
+              </a:spcBef>
+              <a:spcAft>
+                <a:spcPts val="0"/>
+              </a:spcAft>
+              <a:buNone/>
+            </a:pPr>
+            <a:endParaRPr lang="en-US" b="0" dirty="0"/>
+          </a:p>
+          <a:p>
+            <a:pPr marL="0" lvl="0" indent="0">
+              <a:spcBef>
+                <a:spcPts val="0"/>
+              </a:spcBef>
+              <a:spcAft>
+                <a:spcPts val="0"/>
+              </a:spcAft>
+              <a:buNone/>
+            </a:pPr>
+            <a:r>
+              <a:rPr lang="en-US" b="0" dirty="0"/>
+              <a:t>The Random Forest regressor showed a continuously better predictive performance compared to XGBoost across all time steps, reaching an average prediction of almost 16.5 minutes, with the RMSE following this trend. Also, the R-squared value shows that 69% of the variance in the dependent variable was explained by the input features. This clearly showed that data quality is preferred over quantity by both models. </a:t>
+            </a:r>
+          </a:p>
+          <a:p>
+            <a:pPr marL="0" lvl="0" indent="0">
+              <a:spcBef>
+                <a:spcPts val="0"/>
+              </a:spcBef>
+              <a:spcAft>
+                <a:spcPts val="0"/>
+              </a:spcAft>
+              <a:buNone/>
+            </a:pPr>
+            <a:endParaRPr lang="en-US" b="0" dirty="0"/>
+          </a:p>
+          <a:p>
+            <a:pPr marL="0" lvl="0" indent="0">
+              <a:spcBef>
+                <a:spcPts val="0"/>
+              </a:spcBef>
+              <a:spcAft>
+                <a:spcPts val="0"/>
+              </a:spcAft>
+              <a:buNone/>
+            </a:pPr>
+            <a:r>
+              <a:rPr lang="en-US" b="0" dirty="0"/>
+              <a:t>Moreover, with a best benchmark MAE of 21.39 minutes, such methodological decisions and experimental designs in this study improved the predictive capabilities of the models by nearly 4 minutes and showed that Linear Regression is less applicable in this domain. One can also argue that XGBoost might be better when given a diverse demographic dataset.</a:t>
+            </a:r>
+          </a:p>
+          <a:p>
+            <a:pPr marL="0" lvl="0" indent="0">
+              <a:spcBef>
+                <a:spcPts val="0"/>
+              </a:spcBef>
+              <a:spcAft>
+                <a:spcPts val="0"/>
+              </a:spcAft>
+              <a:buNone/>
+            </a:pPr>
+            <a:endParaRPr lang="en-US" b="0" dirty="0"/>
+          </a:p>
+          <a:p>
+            <a:pPr marL="0" lvl="0" indent="0">
+              <a:spcBef>
+                <a:spcPts val="0"/>
+              </a:spcBef>
+              <a:spcAft>
+                <a:spcPts val="0"/>
+              </a:spcAft>
+              <a:buNone/>
+            </a:pPr>
+            <a:r>
+              <a:rPr lang="en-US" b="0" dirty="0"/>
+              <a:t>It is important to note that the shaded area within the graphs is the standard deviation obtained from the repeated experiments.</a:t>
+            </a:r>
+          </a:p>
+        </p:txBody>
+      </p:sp>
+    </p:spTree>
+    <p:extLst>
+      <p:ext uri="{BB962C8B-B14F-4D97-AF65-F5344CB8AC3E}">
+        <p14:creationId xmlns:p14="http://schemas.microsoft.com/office/powerpoint/2010/main" val="4039395237"/>
+      </p:ext>
+    </p:extLst>
+  </p:cSld>
+  <p:clrMapOvr>
+    <a:masterClrMapping/>
+  </p:clrMapOvr>
+</p:notes>
+</file>
+
+<file path=ppt/notesSlides/notesSlide8.xml><?xml version="1.0" encoding="utf-8"?>
 <p:notes xmlns:a="http://schemas.openxmlformats.org/drawingml/2006/main" xmlns:r="http://schemas.openxmlformats.org/officeDocument/2006/relationships" xmlns:p="http://schemas.openxmlformats.org/presentationml/2006/main" showMasterSp="0" showMasterPhAnim="0">
   <p:cSld>
     <p:spTree>
@@ -1587,7 +2075,7 @@
           </a:bodyPr>
           <a:lstStyle/>
           <a:p>
-            <a:pPr marL="171450" lvl="0" indent="-171450">
+            <a:pPr marL="0" lvl="0" indent="0">
               <a:spcBef>
                 <a:spcPts val="0"/>
               </a:spcBef>
@@ -1595,9 +2083,41 @@
                 <a:spcPts val="0"/>
               </a:spcAft>
               <a:buFont typeface="Arial" panose="020B0604020202020204" pitchFamily="34" charset="0"/>
-              <a:buChar char="•"/>
+              <a:buNone/>
             </a:pPr>
-            <a:endParaRPr lang="en-US" b="1" dirty="0"/>
+            <a:r>
+              <a:rPr lang="en-US" b="0" dirty="0"/>
+              <a:t>Reflecting on the first research question, it can be confidently said that Random Forest was the superior model in this specific scenario. Also, for the second research question, the amount of historical data does affect the predictive accuracy of the models since it improved closer to race day.</a:t>
+            </a:r>
+          </a:p>
+          <a:p>
+            <a:pPr marL="0" lvl="0" indent="0">
+              <a:spcBef>
+                <a:spcPts val="0"/>
+              </a:spcBef>
+              <a:spcAft>
+                <a:spcPts val="0"/>
+              </a:spcAft>
+              <a:buFont typeface="Arial" panose="020B0604020202020204" pitchFamily="34" charset="0"/>
+              <a:buNone/>
+            </a:pPr>
+            <a:endParaRPr lang="en-US" b="0" dirty="0"/>
+          </a:p>
+          <a:p>
+            <a:pPr marL="0" lvl="0" indent="0">
+              <a:spcBef>
+                <a:spcPts val="0"/>
+              </a:spcBef>
+              <a:spcAft>
+                <a:spcPts val="0"/>
+              </a:spcAft>
+              <a:buFont typeface="Arial" panose="020B0604020202020204" pitchFamily="34" charset="0"/>
+              <a:buNone/>
+            </a:pPr>
+            <a:r>
+              <a:rPr lang="en-US" b="0" dirty="0"/>
+              <a:t>In addressing the original hypothesis, this can be rejected, and it can be stated that Random Forest achieved the best predictive performance at Week 6, rather than XGBoost being the superior model at Week 16. Thus, this shows the strength of simpler tree-based machine learning models.</a:t>
+            </a:r>
           </a:p>
         </p:txBody>
       </p:sp>
@@ -1614,7 +2134,7 @@
 </p:notes>
 </file>
 
-<file path=ppt/notesSlides/notesSlide8.xml><?xml version="1.0" encoding="utf-8"?>
+<file path=ppt/notesSlides/notesSlide9.xml><?xml version="1.0" encoding="utf-8"?>
 <p:notes xmlns:a="http://schemas.openxmlformats.org/drawingml/2006/main" xmlns:r="http://schemas.openxmlformats.org/officeDocument/2006/relationships" xmlns:p="http://schemas.openxmlformats.org/presentationml/2006/main" showMasterSp="0" showMasterPhAnim="0">
   <p:cSld>
     <p:spTree>
@@ -1715,6 +2235,22 @@
           </a:bodyPr>
           <a:lstStyle/>
           <a:p>
+            <a:pPr marL="0" lvl="0" indent="0">
+              <a:spcBef>
+                <a:spcPts val="0"/>
+              </a:spcBef>
+              <a:spcAft>
+                <a:spcPts val="0"/>
+              </a:spcAft>
+              <a:buFont typeface="Arial" panose="020B0604020202020204" pitchFamily="34" charset="0"/>
+              <a:buNone/>
+            </a:pPr>
+            <a:r>
+              <a:rPr lang="en-US" dirty="0"/>
+              <a:t>Despite successful results, the model faces two main limitations: </a:t>
+            </a:r>
+          </a:p>
+          <a:p>
             <a:pPr marL="171450" lvl="0" indent="-171450">
               <a:spcBef>
                 <a:spcPts val="0"/>
@@ -1722,10 +2258,59 @@
               <a:spcAft>
                 <a:spcPts val="0"/>
               </a:spcAft>
+              <a:buFontTx/>
+              <a:buChar char="-"/>
+            </a:pPr>
+            <a:r>
+              <a:rPr lang="en-US" dirty="0"/>
+              <a:t>Its focus on a single demographic restricts generalizability</a:t>
+            </a:r>
+          </a:p>
+          <a:p>
+            <a:pPr marL="171450" lvl="0" indent="-171450">
+              <a:spcBef>
+                <a:spcPts val="0"/>
+              </a:spcBef>
+              <a:spcAft>
+                <a:spcPts val="0"/>
+              </a:spcAft>
+              <a:buFontTx/>
+              <a:buChar char="-"/>
+            </a:pPr>
+            <a:r>
+              <a:rPr lang="en-US" dirty="0"/>
+              <a:t>And a lack of data excludes the Tokyo Marathon, limiting its applicability to the other five majors</a:t>
+            </a:r>
+          </a:p>
+          <a:p>
+            <a:pPr marL="0" lvl="0" indent="0">
+              <a:spcBef>
+                <a:spcPts val="0"/>
+              </a:spcBef>
+              <a:spcAft>
+                <a:spcPts val="0"/>
+              </a:spcAft>
               <a:buFont typeface="Arial" panose="020B0604020202020204" pitchFamily="34" charset="0"/>
-              <a:buChar char="•"/>
+              <a:buNone/>
             </a:pPr>
-            <a:endParaRPr lang="en-US" b="1" dirty="0"/>
+            <a:endParaRPr lang="en-US" dirty="0"/>
+          </a:p>
+          <a:p>
+            <a:pPr marL="0" lvl="0" indent="0">
+              <a:spcBef>
+                <a:spcPts val="0"/>
+              </a:spcBef>
+              <a:spcAft>
+                <a:spcPts val="0"/>
+              </a:spcAft>
+              <a:buFont typeface="Arial" panose="020B0604020202020204" pitchFamily="34" charset="0"/>
+              <a:buNone/>
+            </a:pPr>
+            <a:r>
+              <a:rPr lang="en-US" dirty="0"/>
+              <a:t>Future work should expand to broader demographics, optimize predictions through hyperparameter tuning, and explore alternative tree-based regressors like LightGBM.</a:t>
+            </a:r>
+            <a:endParaRPr lang="en-US" b="0" dirty="0"/>
           </a:p>
         </p:txBody>
       </p:sp>
@@ -1733,115 +2318,6 @@
     <p:extLst>
       <p:ext uri="{BB962C8B-B14F-4D97-AF65-F5344CB8AC3E}">
         <p14:creationId xmlns:p14="http://schemas.microsoft.com/office/powerpoint/2010/main" val="884829919"/>
-      </p:ext>
-    </p:extLst>
-  </p:cSld>
-  <p:clrMapOvr>
-    <a:masterClrMapping/>
-  </p:clrMapOvr>
-</p:notes>
-</file>
-
-<file path=ppt/notesSlides/notesSlide9.xml><?xml version="1.0" encoding="utf-8"?>
-<p:notes xmlns:a="http://schemas.openxmlformats.org/drawingml/2006/main" xmlns:r="http://schemas.openxmlformats.org/officeDocument/2006/relationships" xmlns:p="http://schemas.openxmlformats.org/presentationml/2006/main" showMasterSp="0" showMasterPhAnim="0">
-  <p:cSld>
-    <p:spTree>
-      <p:nvGrpSpPr>
-        <p:cNvPr id="1" name="Shape 56"/>
-        <p:cNvGrpSpPr/>
-        <p:nvPr/>
-      </p:nvGrpSpPr>
-      <p:grpSpPr>
-        <a:xfrm>
-          <a:off x="0" y="0"/>
-          <a:ext cx="0" cy="0"/>
-          <a:chOff x="0" y="0"/>
-          <a:chExt cx="0" cy="0"/>
-        </a:xfrm>
-      </p:grpSpPr>
-      <p:sp>
-        <p:nvSpPr>
-          <p:cNvPr id="57" name="Shape 57"/>
-          <p:cNvSpPr>
-            <a:spLocks noGrp="1" noRot="1" noChangeAspect="1"/>
-          </p:cNvSpPr>
-          <p:nvPr>
-            <p:ph type="sldImg" idx="2"/>
-          </p:nvPr>
-        </p:nvSpPr>
-        <p:spPr>
-          <a:xfrm>
-            <a:off x="381000" y="685800"/>
-            <a:ext cx="6096000" cy="3429000"/>
-          </a:xfrm>
-          <a:custGeom>
-            <a:avLst/>
-            <a:gdLst/>
-            <a:ahLst/>
-            <a:cxnLst/>
-            <a:rect l="0" t="0" r="0" b="0"/>
-            <a:pathLst>
-              <a:path w="120000" h="120000" extrusionOk="0">
-                <a:moveTo>
-                  <a:pt x="0" y="0"/>
-                </a:moveTo>
-                <a:lnTo>
-                  <a:pt x="120000" y="0"/>
-                </a:lnTo>
-                <a:lnTo>
-                  <a:pt x="120000" y="120000"/>
-                </a:lnTo>
-                <a:lnTo>
-                  <a:pt x="0" y="120000"/>
-                </a:lnTo>
-                <a:close/>
-              </a:path>
-            </a:pathLst>
-          </a:custGeom>
-        </p:spPr>
-      </p:sp>
-      <p:sp>
-        <p:nvSpPr>
-          <p:cNvPr id="58" name="Shape 58"/>
-          <p:cNvSpPr txBox="1">
-            <a:spLocks noGrp="1"/>
-          </p:cNvSpPr>
-          <p:nvPr>
-            <p:ph type="body" idx="1"/>
-          </p:nvPr>
-        </p:nvSpPr>
-        <p:spPr>
-          <a:xfrm>
-            <a:off x="685800" y="4343400"/>
-            <a:ext cx="5486400" cy="4114800"/>
-          </a:xfrm>
-          <a:prstGeom prst="rect">
-            <a:avLst/>
-          </a:prstGeom>
-        </p:spPr>
-        <p:txBody>
-          <a:bodyPr spcFirstLastPara="1" wrap="square" lIns="91425" tIns="91425" rIns="91425" bIns="91425" anchor="t" anchorCtr="0">
-            <a:noAutofit/>
-          </a:bodyPr>
-          <a:lstStyle/>
-          <a:p>
-            <a:pPr marL="0" lvl="0" indent="0">
-              <a:spcBef>
-                <a:spcPts val="0"/>
-              </a:spcBef>
-              <a:spcAft>
-                <a:spcPts val="0"/>
-              </a:spcAft>
-              <a:buNone/>
-            </a:pPr>
-            <a:endParaRPr dirty="0"/>
-          </a:p>
-        </p:txBody>
-      </p:sp>
-    </p:spTree>
-    <p:extLst>
-      <p:ext uri="{BB962C8B-B14F-4D97-AF65-F5344CB8AC3E}">
-        <p14:creationId xmlns:p14="http://schemas.microsoft.com/office/powerpoint/2010/main" val="3294784187"/>
       </p:ext>
     </p:extLst>
   </p:cSld>
@@ -6753,6 +7229,336 @@
   <p:cSld>
     <p:spTree>
       <p:nvGrpSpPr>
+        <p:cNvPr id="1" name="Shape 59"/>
+        <p:cNvGrpSpPr/>
+        <p:nvPr/>
+      </p:nvGrpSpPr>
+      <p:grpSpPr>
+        <a:xfrm>
+          <a:off x="0" y="0"/>
+          <a:ext cx="0" cy="0"/>
+          <a:chOff x="0" y="0"/>
+          <a:chExt cx="0" cy="0"/>
+        </a:xfrm>
+      </p:grpSpPr>
+      <p:sp>
+        <p:nvSpPr>
+          <p:cNvPr id="60" name="Shape 60"/>
+          <p:cNvSpPr txBox="1">
+            <a:spLocks noGrp="1"/>
+          </p:cNvSpPr>
+          <p:nvPr>
+            <p:ph type="title"/>
+          </p:nvPr>
+        </p:nvSpPr>
+        <p:spPr>
+          <a:xfrm>
+            <a:off x="311700" y="445025"/>
+            <a:ext cx="8520600" cy="981900"/>
+          </a:xfrm>
+          <a:prstGeom prst="rect">
+            <a:avLst/>
+          </a:prstGeom>
+        </p:spPr>
+        <p:txBody>
+          <a:bodyPr spcFirstLastPara="1" wrap="square" lIns="91425" tIns="91425" rIns="91425" bIns="91425" anchor="t" anchorCtr="0">
+            <a:noAutofit/>
+          </a:bodyPr>
+          <a:lstStyle/>
+          <a:p>
+            <a:pPr lvl="0" algn="ctr"/>
+            <a:r>
+              <a:rPr lang="en-GB" b="1" dirty="0">
+                <a:latin typeface="Raleway"/>
+                <a:ea typeface="Raleway"/>
+                <a:cs typeface="Raleway"/>
+                <a:sym typeface="Raleway"/>
+              </a:rPr>
+              <a:t>References</a:t>
+            </a:r>
+            <a:endParaRPr sz="2000" b="1" dirty="0">
+              <a:latin typeface="Raleway"/>
+              <a:ea typeface="Raleway"/>
+              <a:cs typeface="Raleway"/>
+              <a:sym typeface="Raleway"/>
+            </a:endParaRPr>
+          </a:p>
+        </p:txBody>
+      </p:sp>
+      <p:cxnSp>
+        <p:nvCxnSpPr>
+          <p:cNvPr id="5" name="Straight Connector 4">
+            <a:extLst>
+              <a:ext uri="{FF2B5EF4-FFF2-40B4-BE49-F238E27FC236}">
+                <a16:creationId xmlns:a16="http://schemas.microsoft.com/office/drawing/2014/main" id="{EE6088A9-71E6-8549-BEC2-BFBC476C30CA}"/>
+              </a:ext>
+            </a:extLst>
+          </p:cNvPr>
+          <p:cNvCxnSpPr/>
+          <p:nvPr/>
+        </p:nvCxnSpPr>
+        <p:spPr>
+          <a:xfrm>
+            <a:off x="112892" y="1002955"/>
+            <a:ext cx="8931965" cy="0"/>
+          </a:xfrm>
+          <a:prstGeom prst="line">
+            <a:avLst/>
+          </a:prstGeom>
+          <a:ln w="38100"/>
+        </p:spPr>
+        <p:style>
+          <a:lnRef idx="1">
+            <a:schemeClr val="accent1"/>
+          </a:lnRef>
+          <a:fillRef idx="0">
+            <a:schemeClr val="accent1"/>
+          </a:fillRef>
+          <a:effectRef idx="0">
+            <a:schemeClr val="accent1"/>
+          </a:effectRef>
+          <a:fontRef idx="minor">
+            <a:schemeClr val="tx1"/>
+          </a:fontRef>
+        </p:style>
+      </p:cxnSp>
+      <p:sp>
+        <p:nvSpPr>
+          <p:cNvPr id="2" name="Text Placeholder 5">
+            <a:extLst>
+              <a:ext uri="{FF2B5EF4-FFF2-40B4-BE49-F238E27FC236}">
+                <a16:creationId xmlns:a16="http://schemas.microsoft.com/office/drawing/2014/main" id="{3EB4467E-1451-F45D-4472-6C2B5E238E4A}"/>
+              </a:ext>
+            </a:extLst>
+          </p:cNvPr>
+          <p:cNvSpPr>
+            <a:spLocks noGrp="1"/>
+          </p:cNvSpPr>
+          <p:nvPr>
+            <p:ph type="body" idx="1"/>
+          </p:nvPr>
+        </p:nvSpPr>
+        <p:spPr>
+          <a:xfrm>
+            <a:off x="316285" y="1176338"/>
+            <a:ext cx="8430046" cy="3344411"/>
+          </a:xfrm>
+        </p:spPr>
+        <p:txBody>
+          <a:bodyPr/>
+          <a:lstStyle/>
+          <a:p>
+            <a:pPr marL="114300" indent="0" algn="just">
+              <a:buNone/>
+            </a:pPr>
+            <a:r>
+              <a:rPr lang="en-US" sz="1000" dirty="0"/>
+              <a:t>[1] D. Ruiz-Mayo, E. Pulido, and G. </a:t>
+            </a:r>
+            <a:r>
+              <a:rPr lang="en-US" sz="1000" dirty="0" err="1"/>
+              <a:t>Martınez</a:t>
+            </a:r>
+            <a:r>
+              <a:rPr lang="en-US" sz="1000" dirty="0"/>
+              <a:t>-Munoz, “Marathon Performance Prediction of Amateur Runners based on Training Session Data.”</a:t>
+            </a:r>
+          </a:p>
+          <a:p>
+            <a:pPr marL="114300" indent="0" algn="just">
+              <a:buNone/>
+            </a:pPr>
+            <a:endParaRPr lang="en-US" sz="1000" dirty="0"/>
+          </a:p>
+          <a:p>
+            <a:pPr marL="114300" indent="0" algn="just">
+              <a:buNone/>
+            </a:pPr>
+            <a:r>
+              <a:rPr lang="en-US" sz="1000" dirty="0"/>
+              <a:t>[2] C. Feely, B. Caulfield, A. Lawlor, and B. Smyth, “Providing Explainable Race-Time Predictions and Training Plan Recommendations to Marathon Runners,” in Fourteenth ACM Conference on Recommender Systems. Virtual Event Brazil: ACM, Sep. 2020, pp. 539–544. [Online]. Available: </a:t>
+            </a:r>
+            <a:r>
+              <a:rPr lang="en-US" sz="1000" dirty="0">
+                <a:hlinkClick r:id="rId3"/>
+              </a:rPr>
+              <a:t>https://dl.acm.org/doi/10.1145/3383313.3412220</a:t>
+            </a:r>
+            <a:endParaRPr lang="en-US" sz="1000" dirty="0"/>
+          </a:p>
+          <a:p>
+            <a:pPr marL="114300" indent="0" algn="just">
+              <a:buNone/>
+            </a:pPr>
+            <a:endParaRPr lang="en-US" sz="1000" dirty="0"/>
+          </a:p>
+          <a:p>
+            <a:pPr marL="114300" indent="0" algn="just">
+              <a:buNone/>
+            </a:pPr>
+            <a:r>
+              <a:rPr lang="en-US" sz="1000" dirty="0"/>
+              <a:t>[3] </a:t>
+            </a:r>
+            <a:r>
+              <a:rPr lang="en-US" sz="1000" dirty="0" err="1"/>
+              <a:t>zuskakluska</a:t>
+            </a:r>
+            <a:r>
+              <a:rPr lang="en-US" sz="1000" dirty="0"/>
+              <a:t>, “Intelligent marathon race predictions,” https://www. kaggle.com/code/</a:t>
+            </a:r>
+            <a:r>
+              <a:rPr lang="en-US" sz="1000" dirty="0" err="1"/>
+              <a:t>zuskakluska</a:t>
+            </a:r>
+            <a:r>
+              <a:rPr lang="en-US" sz="1000" dirty="0"/>
+              <a:t>/intelligent-marathon-race-predictions, 2025, [Online; accessed 11-April-2026].</a:t>
+            </a:r>
+          </a:p>
+          <a:p>
+            <a:pPr marL="114300" indent="0" algn="just">
+              <a:buNone/>
+            </a:pPr>
+            <a:endParaRPr lang="en-US" sz="1000" dirty="0"/>
+          </a:p>
+          <a:p>
+            <a:pPr marL="114300" indent="0" algn="just">
+              <a:buNone/>
+            </a:pPr>
+            <a:r>
+              <a:rPr lang="en-US" sz="1000" dirty="0"/>
+              <a:t>[4] S. Dash, “Win Your Race Goal: A Generalized Approach to Prediction of Running Performance,” Sports Medicine International Open, vol. 08, no. CP, pp. a–2401–6234, Oct. 2024. [Online]. Available: </a:t>
+            </a:r>
+            <a:r>
+              <a:rPr lang="en-US" sz="1000" dirty="0">
+                <a:hlinkClick r:id="rId4"/>
+              </a:rPr>
+              <a:t>http://www.thieme-connect.de/DOI/DOI?10.1055/a-2401-6234</a:t>
+            </a:r>
+            <a:endParaRPr lang="en-US" sz="1000" dirty="0"/>
+          </a:p>
+          <a:p>
+            <a:pPr marL="114300" indent="0" algn="just">
+              <a:buNone/>
+            </a:pPr>
+            <a:endParaRPr lang="en-US" sz="1000" dirty="0"/>
+          </a:p>
+          <a:p>
+            <a:pPr marL="114300" indent="0" algn="just">
+              <a:buNone/>
+            </a:pPr>
+            <a:r>
+              <a:rPr lang="en-US" sz="1000" dirty="0"/>
+              <a:t>[5] L. Lerebourg, D. </a:t>
+            </a:r>
+            <a:r>
+              <a:rPr lang="en-US" sz="1000" dirty="0" err="1"/>
+              <a:t>Saboul</a:t>
+            </a:r>
+            <a:r>
+              <a:rPr lang="en-US" sz="1000" dirty="0"/>
+              <a:t>, M. </a:t>
+            </a:r>
+            <a:r>
+              <a:rPr lang="en-US" sz="1000" dirty="0" err="1"/>
+              <a:t>Cl´emenc¸on</a:t>
+            </a:r>
+            <a:r>
+              <a:rPr lang="en-US" sz="1000" dirty="0"/>
+              <a:t>, and J. B. </a:t>
+            </a:r>
+            <a:r>
+              <a:rPr lang="en-US" sz="1000" dirty="0" err="1"/>
+              <a:t>Coquart</a:t>
+            </a:r>
+            <a:r>
+              <a:rPr lang="en-US" sz="1000" dirty="0"/>
+              <a:t>, “Prediction of Marathon Performance using Artificial Intelligence,” International Journal of Sports Medicine, vol. 44, no. 05, pp. 352–360, May 2023. [Online]. Available: http://www.thieme-connect.de/DOI/DOI?10.1055/ a-1993-2371</a:t>
+            </a:r>
+          </a:p>
+          <a:p>
+            <a:pPr marL="114300" indent="0" algn="just">
+              <a:buNone/>
+            </a:pPr>
+            <a:endParaRPr lang="en-US" sz="1000" dirty="0"/>
+          </a:p>
+          <a:p>
+            <a:pPr marL="114300" indent="0" algn="just">
+              <a:buNone/>
+            </a:pPr>
+            <a:r>
+              <a:rPr lang="en-US" sz="1000" dirty="0"/>
+              <a:t>[6] H. T. El-Kassabi, K. Khalil, and M. A. </a:t>
+            </a:r>
+            <a:r>
+              <a:rPr lang="en-US" sz="1000" dirty="0" err="1"/>
+              <a:t>Serhani</a:t>
+            </a:r>
+            <a:r>
+              <a:rPr lang="en-US" sz="1000" dirty="0"/>
+              <a:t>, “Deep Learning Approach for Forecasting Athletes’ Performance in Sports Tournaments,” in Proceedings of the 13th International Conference on Intelligent Systems: Theories and Applications. Rabat Morocco: ACM, Sep. 2020, pp. 1–6. [Online]. Available: https://dl.acm.org/doi/10.1145/3419604.3419786</a:t>
+            </a:r>
+          </a:p>
+          <a:p>
+            <a:pPr marL="114300" indent="0">
+              <a:buNone/>
+            </a:pPr>
+            <a:endParaRPr lang="en-US" sz="1050" dirty="0"/>
+          </a:p>
+          <a:p>
+            <a:pPr marL="114300" indent="0">
+              <a:buNone/>
+            </a:pPr>
+            <a:endParaRPr lang="en-US" sz="1050" dirty="0"/>
+          </a:p>
+          <a:p>
+            <a:pPr marL="114300" indent="0">
+              <a:buNone/>
+            </a:pPr>
+            <a:endParaRPr lang="en-US" sz="1050" dirty="0"/>
+          </a:p>
+          <a:p>
+            <a:pPr lvl="1">
+              <a:spcBef>
+                <a:spcPts val="0"/>
+              </a:spcBef>
+            </a:pPr>
+            <a:endParaRPr lang="en-US" sz="800" dirty="0"/>
+          </a:p>
+          <a:p>
+            <a:pPr marL="596900" lvl="1" indent="0">
+              <a:spcBef>
+                <a:spcPts val="0"/>
+              </a:spcBef>
+              <a:buNone/>
+            </a:pPr>
+            <a:endParaRPr lang="en-US" sz="800" dirty="0"/>
+          </a:p>
+          <a:p>
+            <a:endParaRPr lang="en-US" sz="800" dirty="0"/>
+          </a:p>
+        </p:txBody>
+      </p:sp>
+    </p:spTree>
+    <p:extLst>
+      <p:ext uri="{BB962C8B-B14F-4D97-AF65-F5344CB8AC3E}">
+        <p14:creationId xmlns:p14="http://schemas.microsoft.com/office/powerpoint/2010/main" val="1793795348"/>
+      </p:ext>
+    </p:extLst>
+  </p:cSld>
+  <p:clrMapOvr>
+    <a:masterClrMapping/>
+  </p:clrMapOvr>
+</p:sld>
+</file>
+
+<file path=ppt/slides/slide11.xml><?xml version="1.0" encoding="utf-8"?>
+<p:sld xmlns:a="http://schemas.openxmlformats.org/drawingml/2006/main" xmlns:r="http://schemas.openxmlformats.org/officeDocument/2006/relationships" xmlns:p="http://schemas.openxmlformats.org/presentationml/2006/main">
+  <p:cSld>
+    <p:spTree>
+      <p:nvGrpSpPr>
         <p:cNvPr id="1" name=""/>
         <p:cNvGrpSpPr/>
         <p:nvPr/>
@@ -6863,7 +7669,7 @@
           <p:nvPr/>
         </p:nvPicPr>
         <p:blipFill>
-          <a:blip r:embed="rId2"/>
+          <a:blip r:embed="rId3"/>
           <a:stretch>
             <a:fillRect/>
           </a:stretch>
@@ -7017,8 +7823,12 @@
           <a:p>
             <a:pPr algn="just"/>
             <a:r>
+              <a:rPr lang="en-GB" sz="1600" b="1" dirty="0"/>
+              <a:t>Background:</a:t>
+            </a:r>
+            <a:r>
               <a:rPr lang="en-GB" sz="1600" dirty="0"/>
-              <a:t>The popularity of long-distance endurance running led to the importance of predictive race-day algorithms. Such algorithm development remains a challenge.</a:t>
+              <a:t> The popularity of long-distance endurance running led to the importance of predictive race-day algorithms. Such algorithm development remains a challenge.</a:t>
             </a:r>
           </a:p>
           <a:p>
@@ -7204,21 +8014,22 @@
         </p:nvPicPr>
         <p:blipFill>
           <a:blip r:embed="rId3"/>
+          <a:srcRect l="585" t="845" r="1820" b="1512"/>
           <a:stretch>
             <a:fillRect/>
           </a:stretch>
         </p:blipFill>
         <p:spPr>
           <a:xfrm>
-            <a:off x="1904696" y="1121052"/>
-            <a:ext cx="5334607" cy="3813411"/>
+            <a:off x="1934288" y="1145059"/>
+            <a:ext cx="5275423" cy="3772930"/>
           </a:xfrm>
           <a:prstGeom prst="rect">
             <a:avLst/>
           </a:prstGeom>
           <a:ln>
             <a:solidFill>
-              <a:schemeClr val="tx1"/>
+              <a:schemeClr val="bg1"/>
             </a:solidFill>
           </a:ln>
         </p:spPr>
@@ -7265,8 +8076,8 @@
         </p:nvSpPr>
         <p:spPr>
           <a:xfrm>
-            <a:off x="140159" y="2299494"/>
-            <a:ext cx="2539690" cy="544512"/>
+            <a:off x="414564" y="2123356"/>
+            <a:ext cx="1784242" cy="896787"/>
           </a:xfrm>
           <a:prstGeom prst="rect">
             <a:avLst/>
@@ -7321,7 +8132,7 @@
         </p:nvCxnSpPr>
         <p:spPr>
           <a:xfrm flipV="1">
-            <a:off x="2806667" y="357641"/>
+            <a:off x="2551294" y="388768"/>
             <a:ext cx="0" cy="4394732"/>
           </a:xfrm>
           <a:prstGeom prst="line">
@@ -7366,7 +8177,7 @@
         </p:blipFill>
         <p:spPr>
           <a:xfrm>
-            <a:off x="3060305" y="388768"/>
+            <a:off x="2903783" y="388768"/>
             <a:ext cx="5712994" cy="4365964"/>
           </a:xfrm>
           <a:prstGeom prst="rect">
@@ -7504,7 +8315,6 @@
               <a:rPr lang="en-GB" sz="1200" dirty="0"/>
               <a:t>Demographic-specific athlete data</a:t>
             </a:r>
-            <a:endParaRPr lang="en-GB" sz="1100" dirty="0"/>
           </a:p>
           <a:p>
             <a:pPr lvl="1" algn="just"/>
@@ -7524,9 +8334,8 @@
             <a:pPr lvl="1" algn="just"/>
             <a:r>
               <a:rPr lang="en-GB" sz="1200" dirty="0"/>
-              <a:t>K-fold cross-validation technique, and repeated experiments, as adopted by [1] and [4], respectively</a:t>
+              <a:t>10-fold cross-validation technique, and repeated experiments, as adopted by [1] and [4], respectively</a:t>
             </a:r>
-            <a:endParaRPr lang="en-GB" dirty="0"/>
           </a:p>
           <a:p>
             <a:pPr algn="just"/>
@@ -7658,7 +8467,7 @@
                 <a:cs typeface="Raleway"/>
                 <a:sym typeface="Raleway"/>
               </a:rPr>
-              <a:t>Results &amp; Findings</a:t>
+              <a:t>Benchmark Model Results</a:t>
             </a:r>
             <a:endParaRPr sz="2000" b="1" dirty="0">
               <a:latin typeface="Raleway"/>
@@ -7762,12 +8571,588 @@
           </a:p>
         </p:txBody>
       </p:sp>
+      <p:graphicFrame>
+        <p:nvGraphicFramePr>
+          <p:cNvPr id="2" name="Table 1">
+            <a:extLst>
+              <a:ext uri="{FF2B5EF4-FFF2-40B4-BE49-F238E27FC236}">
+                <a16:creationId xmlns:a16="http://schemas.microsoft.com/office/drawing/2014/main" id="{ECC15834-F224-3F58-CF84-B62ADDD003F5}"/>
+              </a:ext>
+            </a:extLst>
+          </p:cNvPr>
+          <p:cNvGraphicFramePr>
+            <a:graphicFrameLocks noGrp="1"/>
+          </p:cNvGraphicFramePr>
+          <p:nvPr>
+            <p:extLst>
+              <p:ext uri="{D42A27DB-BD31-4B8C-83A1-F6EECF244321}">
+                <p14:modId xmlns:p14="http://schemas.microsoft.com/office/powerpoint/2010/main" val="4034444422"/>
+              </p:ext>
+            </p:extLst>
+          </p:nvPr>
+        </p:nvGraphicFramePr>
+        <p:xfrm>
+          <a:off x="756516" y="2106863"/>
+          <a:ext cx="7644715" cy="1483360"/>
+        </p:xfrm>
+        <a:graphic>
+          <a:graphicData uri="http://schemas.openxmlformats.org/drawingml/2006/table">
+            <a:tbl>
+              <a:tblPr firstRow="1" bandRow="1">
+                <a:tableStyleId>{073A0DAA-6AF3-43AB-8588-CEC1D06C72B9}</a:tableStyleId>
+              </a:tblPr>
+              <a:tblGrid>
+                <a:gridCol w="908416">
+                  <a:extLst>
+                    <a:ext uri="{9D8B030D-6E8A-4147-A177-3AD203B41FA5}">
+                      <a16:colId xmlns:a16="http://schemas.microsoft.com/office/drawing/2014/main" val="4021976425"/>
+                    </a:ext>
+                  </a:extLst>
+                </a:gridCol>
+                <a:gridCol w="1631092">
+                  <a:extLst>
+                    <a:ext uri="{9D8B030D-6E8A-4147-A177-3AD203B41FA5}">
+                      <a16:colId xmlns:a16="http://schemas.microsoft.com/office/drawing/2014/main" val="3345559796"/>
+                    </a:ext>
+                  </a:extLst>
+                </a:gridCol>
+                <a:gridCol w="1729946">
+                  <a:extLst>
+                    <a:ext uri="{9D8B030D-6E8A-4147-A177-3AD203B41FA5}">
+                      <a16:colId xmlns:a16="http://schemas.microsoft.com/office/drawing/2014/main" val="3717243362"/>
+                    </a:ext>
+                  </a:extLst>
+                </a:gridCol>
+                <a:gridCol w="1729946">
+                  <a:extLst>
+                    <a:ext uri="{9D8B030D-6E8A-4147-A177-3AD203B41FA5}">
+                      <a16:colId xmlns:a16="http://schemas.microsoft.com/office/drawing/2014/main" val="1693119483"/>
+                    </a:ext>
+                  </a:extLst>
+                </a:gridCol>
+                <a:gridCol w="1645315">
+                  <a:extLst>
+                    <a:ext uri="{9D8B030D-6E8A-4147-A177-3AD203B41FA5}">
+                      <a16:colId xmlns:a16="http://schemas.microsoft.com/office/drawing/2014/main" val="3133263432"/>
+                    </a:ext>
+                  </a:extLst>
+                </a:gridCol>
+              </a:tblGrid>
+              <a:tr h="370840">
+                <a:tc>
+                  <a:txBody>
+                    <a:bodyPr/>
+                    <a:lstStyle/>
+                    <a:p>
+                      <a:pPr algn="ctr"/>
+                      <a:r>
+                        <a:rPr lang="en-US" dirty="0"/>
+                        <a:t>Weeks</a:t>
+                      </a:r>
+                      <a:endParaRPr lang="en-MT" dirty="0"/>
+                    </a:p>
+                  </a:txBody>
+                  <a:tcPr/>
+                </a:tc>
+                <a:tc>
+                  <a:txBody>
+                    <a:bodyPr/>
+                    <a:lstStyle/>
+                    <a:p>
+                      <a:pPr algn="ctr"/>
+                      <a:r>
+                        <a:rPr lang="en-US" dirty="0"/>
+                        <a:t>Model</a:t>
+                      </a:r>
+                      <a:endParaRPr lang="en-MT" dirty="0"/>
+                    </a:p>
+                  </a:txBody>
+                  <a:tcPr/>
+                </a:tc>
+                <a:tc>
+                  <a:txBody>
+                    <a:bodyPr/>
+                    <a:lstStyle/>
+                    <a:p>
+                      <a:pPr algn="ctr"/>
+                      <a:r>
+                        <a:rPr lang="en-US" dirty="0"/>
+                        <a:t>MAE (mins)</a:t>
+                      </a:r>
+                      <a:endParaRPr lang="en-MT" dirty="0"/>
+                    </a:p>
+                  </a:txBody>
+                  <a:tcPr/>
+                </a:tc>
+                <a:tc>
+                  <a:txBody>
+                    <a:bodyPr/>
+                    <a:lstStyle/>
+                    <a:p>
+                      <a:pPr algn="ctr"/>
+                      <a:r>
+                        <a:rPr lang="en-US" dirty="0"/>
+                        <a:t>RMSE (mins)</a:t>
+                      </a:r>
+                      <a:endParaRPr lang="en-MT" dirty="0"/>
+                    </a:p>
+                  </a:txBody>
+                  <a:tcPr/>
+                </a:tc>
+                <a:tc>
+                  <a:txBody>
+                    <a:bodyPr/>
+                    <a:lstStyle/>
+                    <a:p>
+                      <a:pPr algn="ctr"/>
+                      <a:r>
+                        <a:rPr lang="en-US" dirty="0"/>
+                        <a:t>R-squared Score</a:t>
+                      </a:r>
+                      <a:endParaRPr lang="en-MT" dirty="0"/>
+                    </a:p>
+                  </a:txBody>
+                  <a:tcPr/>
+                </a:tc>
+                <a:extLst>
+                  <a:ext uri="{0D108BD9-81ED-4DB2-BD59-A6C34878D82A}">
+                    <a16:rowId xmlns:a16="http://schemas.microsoft.com/office/drawing/2014/main" val="1547635987"/>
+                  </a:ext>
+                </a:extLst>
+              </a:tr>
+              <a:tr h="370840">
+                <a:tc rowSpan="3">
+                  <a:txBody>
+                    <a:bodyPr/>
+                    <a:lstStyle/>
+                    <a:p>
+                      <a:pPr algn="ctr"/>
+                      <a:r>
+                        <a:rPr lang="en-US" dirty="0"/>
+                        <a:t>N/A</a:t>
+                      </a:r>
+                      <a:endParaRPr lang="en-MT" dirty="0"/>
+                    </a:p>
+                  </a:txBody>
+                  <a:tcPr anchor="ctr"/>
+                </a:tc>
+                <a:tc>
+                  <a:txBody>
+                    <a:bodyPr/>
+                    <a:lstStyle/>
+                    <a:p>
+                      <a:pPr algn="ctr"/>
+                      <a:r>
+                        <a:rPr lang="en-US" dirty="0"/>
+                        <a:t>Linear Regression</a:t>
+                      </a:r>
+                      <a:endParaRPr lang="en-MT" dirty="0"/>
+                    </a:p>
+                  </a:txBody>
+                  <a:tcPr/>
+                </a:tc>
+                <a:tc>
+                  <a:txBody>
+                    <a:bodyPr/>
+                    <a:lstStyle/>
+                    <a:p>
+                      <a:pPr algn="ctr"/>
+                      <a:r>
+                        <a:rPr lang="en-US" dirty="0"/>
+                        <a:t>27.98</a:t>
+                      </a:r>
+                      <a:endParaRPr lang="en-MT" dirty="0"/>
+                    </a:p>
+                  </a:txBody>
+                  <a:tcPr/>
+                </a:tc>
+                <a:tc>
+                  <a:txBody>
+                    <a:bodyPr/>
+                    <a:lstStyle/>
+                    <a:p>
+                      <a:pPr algn="ctr"/>
+                      <a:r>
+                        <a:rPr lang="en-US" dirty="0"/>
+                        <a:t>36.76</a:t>
+                      </a:r>
+                      <a:endParaRPr lang="en-MT" dirty="0"/>
+                    </a:p>
+                  </a:txBody>
+                  <a:tcPr/>
+                </a:tc>
+                <a:tc>
+                  <a:txBody>
+                    <a:bodyPr/>
+                    <a:lstStyle/>
+                    <a:p>
+                      <a:pPr algn="ctr"/>
+                      <a:r>
+                        <a:rPr lang="en-US" dirty="0"/>
+                        <a:t>0.47</a:t>
+                      </a:r>
+                      <a:endParaRPr lang="en-MT" dirty="0"/>
+                    </a:p>
+                  </a:txBody>
+                  <a:tcPr/>
+                </a:tc>
+                <a:extLst>
+                  <a:ext uri="{0D108BD9-81ED-4DB2-BD59-A6C34878D82A}">
+                    <a16:rowId xmlns:a16="http://schemas.microsoft.com/office/drawing/2014/main" val="605514787"/>
+                  </a:ext>
+                </a:extLst>
+              </a:tr>
+              <a:tr h="370840">
+                <a:tc vMerge="1">
+                  <a:txBody>
+                    <a:bodyPr/>
+                    <a:lstStyle/>
+                    <a:p>
+                      <a:endParaRPr lang="en-MT" dirty="0"/>
+                    </a:p>
+                  </a:txBody>
+                  <a:tcPr/>
+                </a:tc>
+                <a:tc>
+                  <a:txBody>
+                    <a:bodyPr/>
+                    <a:lstStyle/>
+                    <a:p>
+                      <a:pPr algn="ctr"/>
+                      <a:r>
+                        <a:rPr lang="en-US" dirty="0"/>
+                        <a:t>Random Forest</a:t>
+                      </a:r>
+                      <a:endParaRPr lang="en-MT" dirty="0"/>
+                    </a:p>
+                  </a:txBody>
+                  <a:tcPr/>
+                </a:tc>
+                <a:tc>
+                  <a:txBody>
+                    <a:bodyPr/>
+                    <a:lstStyle/>
+                    <a:p>
+                      <a:pPr algn="ctr"/>
+                      <a:r>
+                        <a:rPr lang="en-US" dirty="0"/>
+                        <a:t>21.84</a:t>
+                      </a:r>
+                      <a:endParaRPr lang="en-MT" dirty="0"/>
+                    </a:p>
+                  </a:txBody>
+                  <a:tcPr/>
+                </a:tc>
+                <a:tc>
+                  <a:txBody>
+                    <a:bodyPr/>
+                    <a:lstStyle/>
+                    <a:p>
+                      <a:pPr algn="ctr"/>
+                      <a:r>
+                        <a:rPr lang="en-US" dirty="0"/>
+                        <a:t>30.15</a:t>
+                      </a:r>
+                      <a:endParaRPr lang="en-MT" dirty="0"/>
+                    </a:p>
+                  </a:txBody>
+                  <a:tcPr/>
+                </a:tc>
+                <a:tc>
+                  <a:txBody>
+                    <a:bodyPr/>
+                    <a:lstStyle/>
+                    <a:p>
+                      <a:pPr algn="ctr"/>
+                      <a:r>
+                        <a:rPr lang="en-US" dirty="0"/>
+                        <a:t>0.64</a:t>
+                      </a:r>
+                      <a:endParaRPr lang="en-MT" dirty="0"/>
+                    </a:p>
+                  </a:txBody>
+                  <a:tcPr/>
+                </a:tc>
+                <a:extLst>
+                  <a:ext uri="{0D108BD9-81ED-4DB2-BD59-A6C34878D82A}">
+                    <a16:rowId xmlns:a16="http://schemas.microsoft.com/office/drawing/2014/main" val="2734563832"/>
+                  </a:ext>
+                </a:extLst>
+              </a:tr>
+              <a:tr h="370840">
+                <a:tc vMerge="1">
+                  <a:txBody>
+                    <a:bodyPr/>
+                    <a:lstStyle/>
+                    <a:p>
+                      <a:endParaRPr lang="en-MT" dirty="0"/>
+                    </a:p>
+                  </a:txBody>
+                  <a:tcPr/>
+                </a:tc>
+                <a:tc>
+                  <a:txBody>
+                    <a:bodyPr/>
+                    <a:lstStyle/>
+                    <a:p>
+                      <a:pPr algn="ctr"/>
+                      <a:r>
+                        <a:rPr lang="en-US" dirty="0"/>
+                        <a:t>XGBoost</a:t>
+                      </a:r>
+                      <a:endParaRPr lang="en-MT" dirty="0"/>
+                    </a:p>
+                  </a:txBody>
+                  <a:tcPr/>
+                </a:tc>
+                <a:tc>
+                  <a:txBody>
+                    <a:bodyPr/>
+                    <a:lstStyle/>
+                    <a:p>
+                      <a:pPr algn="ctr"/>
+                      <a:r>
+                        <a:rPr lang="en-US" dirty="0"/>
+                        <a:t>21.39</a:t>
+                      </a:r>
+                      <a:endParaRPr lang="en-MT" dirty="0"/>
+                    </a:p>
+                  </a:txBody>
+                  <a:tcPr/>
+                </a:tc>
+                <a:tc>
+                  <a:txBody>
+                    <a:bodyPr/>
+                    <a:lstStyle/>
+                    <a:p>
+                      <a:pPr algn="ctr"/>
+                      <a:r>
+                        <a:rPr lang="en-US" dirty="0"/>
+                        <a:t>29.68</a:t>
+                      </a:r>
+                      <a:endParaRPr lang="en-MT" dirty="0"/>
+                    </a:p>
+                  </a:txBody>
+                  <a:tcPr/>
+                </a:tc>
+                <a:tc>
+                  <a:txBody>
+                    <a:bodyPr/>
+                    <a:lstStyle/>
+                    <a:p>
+                      <a:pPr algn="ctr"/>
+                      <a:r>
+                        <a:rPr lang="en-US" dirty="0"/>
+                        <a:t>0.65</a:t>
+                      </a:r>
+                      <a:endParaRPr lang="en-MT" dirty="0"/>
+                    </a:p>
+                  </a:txBody>
+                  <a:tcPr/>
+                </a:tc>
+                <a:extLst>
+                  <a:ext uri="{0D108BD9-81ED-4DB2-BD59-A6C34878D82A}">
+                    <a16:rowId xmlns:a16="http://schemas.microsoft.com/office/drawing/2014/main" val="3840799247"/>
+                  </a:ext>
+                </a:extLst>
+              </a:tr>
+            </a:tbl>
+          </a:graphicData>
+        </a:graphic>
+      </p:graphicFrame>
+    </p:spTree>
+    <p:extLst>
+      <p:ext uri="{BB962C8B-B14F-4D97-AF65-F5344CB8AC3E}">
+        <p14:creationId xmlns:p14="http://schemas.microsoft.com/office/powerpoint/2010/main" val="73567660"/>
+      </p:ext>
+    </p:extLst>
+  </p:cSld>
+  <p:clrMapOvr>
+    <a:masterClrMapping/>
+  </p:clrMapOvr>
+</p:sld>
+</file>
+
+<file path=ppt/slides/slide7.xml><?xml version="1.0" encoding="utf-8"?>
+<p:sld xmlns:a="http://schemas.openxmlformats.org/drawingml/2006/main" xmlns:r="http://schemas.openxmlformats.org/officeDocument/2006/relationships" xmlns:p="http://schemas.openxmlformats.org/presentationml/2006/main">
+  <p:cSld>
+    <p:spTree>
+      <p:nvGrpSpPr>
+        <p:cNvPr id="1" name="Shape 59">
+          <a:extLst>
+            <a:ext uri="{FF2B5EF4-FFF2-40B4-BE49-F238E27FC236}">
+              <a16:creationId xmlns:a16="http://schemas.microsoft.com/office/drawing/2014/main" id="{92B9FD50-8CF9-F4C9-4538-3094426EA90F}"/>
+            </a:ext>
+          </a:extLst>
+        </p:cNvPr>
+        <p:cNvGrpSpPr/>
+        <p:nvPr/>
+      </p:nvGrpSpPr>
+      <p:grpSpPr>
+        <a:xfrm>
+          <a:off x="0" y="0"/>
+          <a:ext cx="0" cy="0"/>
+          <a:chOff x="0" y="0"/>
+          <a:chExt cx="0" cy="0"/>
+        </a:xfrm>
+      </p:grpSpPr>
+      <p:sp>
+        <p:nvSpPr>
+          <p:cNvPr id="60" name="Shape 60">
+            <a:extLst>
+              <a:ext uri="{FF2B5EF4-FFF2-40B4-BE49-F238E27FC236}">
+                <a16:creationId xmlns:a16="http://schemas.microsoft.com/office/drawing/2014/main" id="{0FF449C1-C188-AE15-328A-A993106C8383}"/>
+              </a:ext>
+            </a:extLst>
+          </p:cNvPr>
+          <p:cNvSpPr txBox="1">
+            <a:spLocks noGrp="1"/>
+          </p:cNvSpPr>
+          <p:nvPr>
+            <p:ph type="title"/>
+          </p:nvPr>
+        </p:nvSpPr>
+        <p:spPr>
+          <a:xfrm>
+            <a:off x="311700" y="445025"/>
+            <a:ext cx="8520600" cy="981900"/>
+          </a:xfrm>
+          <a:prstGeom prst="rect">
+            <a:avLst/>
+          </a:prstGeom>
+        </p:spPr>
+        <p:txBody>
+          <a:bodyPr spcFirstLastPara="1" wrap="square" lIns="91425" tIns="91425" rIns="91425" bIns="91425" anchor="t" anchorCtr="0">
+            <a:noAutofit/>
+          </a:bodyPr>
+          <a:lstStyle/>
+          <a:p>
+            <a:pPr marL="0" lvl="0" indent="0" algn="ctr" rtl="0">
+              <a:spcBef>
+                <a:spcPts val="0"/>
+              </a:spcBef>
+              <a:spcAft>
+                <a:spcPts val="0"/>
+              </a:spcAft>
+              <a:buNone/>
+            </a:pPr>
+            <a:r>
+              <a:rPr lang="en-GB" b="1" dirty="0">
+                <a:latin typeface="Raleway"/>
+                <a:ea typeface="Raleway"/>
+                <a:cs typeface="Raleway"/>
+                <a:sym typeface="Raleway"/>
+              </a:rPr>
+              <a:t>Results &amp; Findings</a:t>
+            </a:r>
+            <a:endParaRPr sz="2000" b="1" dirty="0">
+              <a:latin typeface="Raleway"/>
+              <a:ea typeface="Raleway"/>
+              <a:cs typeface="Raleway"/>
+              <a:sym typeface="Raleway"/>
+            </a:endParaRPr>
+          </a:p>
+        </p:txBody>
+      </p:sp>
+      <p:cxnSp>
+        <p:nvCxnSpPr>
+          <p:cNvPr id="5" name="Straight Connector 4">
+            <a:extLst>
+              <a:ext uri="{FF2B5EF4-FFF2-40B4-BE49-F238E27FC236}">
+                <a16:creationId xmlns:a16="http://schemas.microsoft.com/office/drawing/2014/main" id="{37B5BE8D-EA54-8083-10CB-B2B07D92333A}"/>
+              </a:ext>
+            </a:extLst>
+          </p:cNvPr>
+          <p:cNvCxnSpPr/>
+          <p:nvPr/>
+        </p:nvCxnSpPr>
+        <p:spPr>
+          <a:xfrm>
+            <a:off x="112892" y="1002955"/>
+            <a:ext cx="8931965" cy="0"/>
+          </a:xfrm>
+          <a:prstGeom prst="line">
+            <a:avLst/>
+          </a:prstGeom>
+          <a:ln w="38100"/>
+        </p:spPr>
+        <p:style>
+          <a:lnRef idx="1">
+            <a:schemeClr val="accent1"/>
+          </a:lnRef>
+          <a:fillRef idx="0">
+            <a:schemeClr val="accent1"/>
+          </a:fillRef>
+          <a:effectRef idx="0">
+            <a:schemeClr val="accent1"/>
+          </a:effectRef>
+          <a:fontRef idx="minor">
+            <a:schemeClr val="tx1"/>
+          </a:fontRef>
+        </p:style>
+      </p:cxnSp>
+      <p:sp>
+        <p:nvSpPr>
+          <p:cNvPr id="8" name="Text Placeholder 5">
+            <a:extLst>
+              <a:ext uri="{FF2B5EF4-FFF2-40B4-BE49-F238E27FC236}">
+                <a16:creationId xmlns:a16="http://schemas.microsoft.com/office/drawing/2014/main" id="{B5EF8A3D-0A62-336F-47EE-013B02FD4B4B}"/>
+              </a:ext>
+            </a:extLst>
+          </p:cNvPr>
+          <p:cNvSpPr>
+            <a:spLocks noGrp="1"/>
+          </p:cNvSpPr>
+          <p:nvPr>
+            <p:ph type="body" idx="1"/>
+          </p:nvPr>
+        </p:nvSpPr>
+        <p:spPr>
+          <a:xfrm>
+            <a:off x="316285" y="1176338"/>
+            <a:ext cx="8430046" cy="3344411"/>
+          </a:xfrm>
+        </p:spPr>
+        <p:txBody>
+          <a:bodyPr/>
+          <a:lstStyle/>
+          <a:p>
+            <a:endParaRPr lang="en-US" sz="1050" dirty="0"/>
+          </a:p>
+          <a:p>
+            <a:pPr marL="114300" indent="0">
+              <a:buNone/>
+            </a:pPr>
+            <a:endParaRPr lang="en-US" sz="1050" dirty="0"/>
+          </a:p>
+          <a:p>
+            <a:pPr lvl="1">
+              <a:spcBef>
+                <a:spcPts val="0"/>
+              </a:spcBef>
+            </a:pPr>
+            <a:endParaRPr lang="en-US" sz="800" dirty="0"/>
+          </a:p>
+          <a:p>
+            <a:pPr marL="596900" lvl="1" indent="0">
+              <a:spcBef>
+                <a:spcPts val="0"/>
+              </a:spcBef>
+              <a:buNone/>
+            </a:pPr>
+            <a:endParaRPr lang="en-US" sz="800" dirty="0"/>
+          </a:p>
+          <a:p>
+            <a:endParaRPr lang="en-US" sz="800" dirty="0"/>
+          </a:p>
+        </p:txBody>
+      </p:sp>
       <p:pic>
         <p:nvPicPr>
           <p:cNvPr id="3" name="Picture 2">
             <a:extLst>
               <a:ext uri="{FF2B5EF4-FFF2-40B4-BE49-F238E27FC236}">
-                <a16:creationId xmlns:a16="http://schemas.microsoft.com/office/drawing/2014/main" id="{ADA500F0-BFBE-D7E0-2AE4-1D619C00CEE7}"/>
+                <a16:creationId xmlns:a16="http://schemas.microsoft.com/office/drawing/2014/main" id="{DE632143-5080-A7FE-534D-6D8D39BB8BF7}"/>
               </a:ext>
             </a:extLst>
           </p:cNvPr>
@@ -7784,7 +9169,7 @@
         </p:blipFill>
         <p:spPr>
           <a:xfrm>
-            <a:off x="158142" y="1426925"/>
+            <a:off x="158142" y="1692035"/>
             <a:ext cx="8827715" cy="2563604"/>
           </a:xfrm>
           <a:prstGeom prst="rect">
@@ -7795,7 +9180,7 @@
     </p:spTree>
     <p:extLst>
       <p:ext uri="{BB962C8B-B14F-4D97-AF65-F5344CB8AC3E}">
-        <p14:creationId xmlns:p14="http://schemas.microsoft.com/office/powerpoint/2010/main" val="73567660"/>
+        <p14:creationId xmlns:p14="http://schemas.microsoft.com/office/powerpoint/2010/main" val="939420836"/>
       </p:ext>
     </p:extLst>
   </p:cSld>
@@ -7805,7 +9190,7 @@
 </p:sld>
 </file>
 
-<file path=ppt/slides/slide7.xml><?xml version="1.0" encoding="utf-8"?>
+<file path=ppt/slides/slide8.xml><?xml version="1.0" encoding="utf-8"?>
 <p:sld xmlns:a="http://schemas.openxmlformats.org/drawingml/2006/main" xmlns:r="http://schemas.openxmlformats.org/officeDocument/2006/relationships" xmlns:p="http://schemas.openxmlformats.org/presentationml/2006/main">
   <p:cSld>
     <p:spTree>
@@ -7951,17 +9336,13 @@
             </a:r>
             <a:r>
               <a:rPr lang="en-US" sz="1600" dirty="0"/>
-              <a:t> </a:t>
-            </a:r>
-            <a:r>
-              <a:rPr lang="en-US" sz="1600" i="1" dirty="0"/>
-              <a:t>Which tree-based machine learning regressor obtains the highest predictive performance when forecasting an athlete’s marathon race time?</a:t>
+              <a:t> Which tree-based machine learning regressor obtains the highest predictive performance when forecasting an athlete’s marathon race time?</a:t>
             </a:r>
           </a:p>
           <a:p>
             <a:pPr lvl="1" algn="just"/>
             <a:r>
-              <a:rPr lang="en-US" dirty="0"/>
+              <a:rPr lang="en-US" i="1" dirty="0"/>
               <a:t>Random Forest consistently outperformed XGBoost across all time steps</a:t>
             </a:r>
           </a:p>
@@ -7978,14 +9359,14 @@
               <a:t>RQ2: </a:t>
             </a:r>
             <a:r>
-              <a:rPr lang="en-US" sz="1600" i="1" dirty="0"/>
+              <a:rPr lang="en-US" sz="1600" dirty="0"/>
               <a:t>To what extent does the amount of weekly historical data affect the predictive accuracy?</a:t>
             </a:r>
           </a:p>
           <a:p>
             <a:pPr lvl="1" algn="just"/>
             <a:r>
-              <a:rPr lang="en-US" dirty="0"/>
+              <a:rPr lang="en-US" i="1" dirty="0"/>
               <a:t>Predictive accuracy improved across all timesteps, reaching its peak at Week 6</a:t>
             </a:r>
           </a:p>
@@ -8003,7 +9384,7 @@
             </a:r>
             <a:r>
               <a:rPr lang="en-US" sz="1600" dirty="0"/>
-              <a:t> The original hypothesis was rejected, provoking the contrary, with Random Forest being the superior model, achieving the best predictive performance at Week 6.</a:t>
+              <a:t> The original hypothesis was rejected, proving the contrary, with Random Forest being the superior model, achieving the best predictive performance at Week 6.</a:t>
             </a:r>
             <a:endParaRPr lang="en-US" sz="1600" b="1" dirty="0"/>
           </a:p>
@@ -8022,7 +9403,7 @@
 </p:sld>
 </file>
 
-<file path=ppt/slides/slide8.xml><?xml version="1.0" encoding="utf-8"?>
+<file path=ppt/slides/slide9.xml><?xml version="1.0" encoding="utf-8"?>
 <p:sld xmlns:a="http://schemas.openxmlformats.org/drawingml/2006/main" xmlns:r="http://schemas.openxmlformats.org/officeDocument/2006/relationships" xmlns:p="http://schemas.openxmlformats.org/presentationml/2006/main">
   <p:cSld>
     <p:spTree>
@@ -8225,336 +9606,6 @@
     <p:extLst>
       <p:ext uri="{BB962C8B-B14F-4D97-AF65-F5344CB8AC3E}">
         <p14:creationId xmlns:p14="http://schemas.microsoft.com/office/powerpoint/2010/main" val="2803103409"/>
-      </p:ext>
-    </p:extLst>
-  </p:cSld>
-  <p:clrMapOvr>
-    <a:masterClrMapping/>
-  </p:clrMapOvr>
-</p:sld>
-</file>
-
-<file path=ppt/slides/slide9.xml><?xml version="1.0" encoding="utf-8"?>
-<p:sld xmlns:a="http://schemas.openxmlformats.org/drawingml/2006/main" xmlns:r="http://schemas.openxmlformats.org/officeDocument/2006/relationships" xmlns:p="http://schemas.openxmlformats.org/presentationml/2006/main">
-  <p:cSld>
-    <p:spTree>
-      <p:nvGrpSpPr>
-        <p:cNvPr id="1" name="Shape 59"/>
-        <p:cNvGrpSpPr/>
-        <p:nvPr/>
-      </p:nvGrpSpPr>
-      <p:grpSpPr>
-        <a:xfrm>
-          <a:off x="0" y="0"/>
-          <a:ext cx="0" cy="0"/>
-          <a:chOff x="0" y="0"/>
-          <a:chExt cx="0" cy="0"/>
-        </a:xfrm>
-      </p:grpSpPr>
-      <p:sp>
-        <p:nvSpPr>
-          <p:cNvPr id="60" name="Shape 60"/>
-          <p:cNvSpPr txBox="1">
-            <a:spLocks noGrp="1"/>
-          </p:cNvSpPr>
-          <p:nvPr>
-            <p:ph type="title"/>
-          </p:nvPr>
-        </p:nvSpPr>
-        <p:spPr>
-          <a:xfrm>
-            <a:off x="311700" y="445025"/>
-            <a:ext cx="8520600" cy="981900"/>
-          </a:xfrm>
-          <a:prstGeom prst="rect">
-            <a:avLst/>
-          </a:prstGeom>
-        </p:spPr>
-        <p:txBody>
-          <a:bodyPr spcFirstLastPara="1" wrap="square" lIns="91425" tIns="91425" rIns="91425" bIns="91425" anchor="t" anchorCtr="0">
-            <a:noAutofit/>
-          </a:bodyPr>
-          <a:lstStyle/>
-          <a:p>
-            <a:pPr lvl="0" algn="ctr"/>
-            <a:r>
-              <a:rPr lang="en-GB" b="1" dirty="0">
-                <a:latin typeface="Raleway"/>
-                <a:ea typeface="Raleway"/>
-                <a:cs typeface="Raleway"/>
-                <a:sym typeface="Raleway"/>
-              </a:rPr>
-              <a:t>References</a:t>
-            </a:r>
-            <a:endParaRPr sz="2000" b="1" dirty="0">
-              <a:latin typeface="Raleway"/>
-              <a:ea typeface="Raleway"/>
-              <a:cs typeface="Raleway"/>
-              <a:sym typeface="Raleway"/>
-            </a:endParaRPr>
-          </a:p>
-        </p:txBody>
-      </p:sp>
-      <p:cxnSp>
-        <p:nvCxnSpPr>
-          <p:cNvPr id="5" name="Straight Connector 4">
-            <a:extLst>
-              <a:ext uri="{FF2B5EF4-FFF2-40B4-BE49-F238E27FC236}">
-                <a16:creationId xmlns:a16="http://schemas.microsoft.com/office/drawing/2014/main" id="{EE6088A9-71E6-8549-BEC2-BFBC476C30CA}"/>
-              </a:ext>
-            </a:extLst>
-          </p:cNvPr>
-          <p:cNvCxnSpPr/>
-          <p:nvPr/>
-        </p:nvCxnSpPr>
-        <p:spPr>
-          <a:xfrm>
-            <a:off x="112892" y="1002955"/>
-            <a:ext cx="8931965" cy="0"/>
-          </a:xfrm>
-          <a:prstGeom prst="line">
-            <a:avLst/>
-          </a:prstGeom>
-          <a:ln w="38100"/>
-        </p:spPr>
-        <p:style>
-          <a:lnRef idx="1">
-            <a:schemeClr val="accent1"/>
-          </a:lnRef>
-          <a:fillRef idx="0">
-            <a:schemeClr val="accent1"/>
-          </a:fillRef>
-          <a:effectRef idx="0">
-            <a:schemeClr val="accent1"/>
-          </a:effectRef>
-          <a:fontRef idx="minor">
-            <a:schemeClr val="tx1"/>
-          </a:fontRef>
-        </p:style>
-      </p:cxnSp>
-      <p:sp>
-        <p:nvSpPr>
-          <p:cNvPr id="2" name="Text Placeholder 5">
-            <a:extLst>
-              <a:ext uri="{FF2B5EF4-FFF2-40B4-BE49-F238E27FC236}">
-                <a16:creationId xmlns:a16="http://schemas.microsoft.com/office/drawing/2014/main" id="{3EB4467E-1451-F45D-4472-6C2B5E238E4A}"/>
-              </a:ext>
-            </a:extLst>
-          </p:cNvPr>
-          <p:cNvSpPr>
-            <a:spLocks noGrp="1"/>
-          </p:cNvSpPr>
-          <p:nvPr>
-            <p:ph type="body" idx="1"/>
-          </p:nvPr>
-        </p:nvSpPr>
-        <p:spPr>
-          <a:xfrm>
-            <a:off x="316285" y="1176338"/>
-            <a:ext cx="8430046" cy="3344411"/>
-          </a:xfrm>
-        </p:spPr>
-        <p:txBody>
-          <a:bodyPr/>
-          <a:lstStyle/>
-          <a:p>
-            <a:pPr marL="114300" indent="0" algn="just">
-              <a:buNone/>
-            </a:pPr>
-            <a:r>
-              <a:rPr lang="en-US" sz="1000" dirty="0"/>
-              <a:t>[1] D. Ruiz-Mayo, E. Pulido, and G. </a:t>
-            </a:r>
-            <a:r>
-              <a:rPr lang="en-US" sz="1000" dirty="0" err="1"/>
-              <a:t>Martınez</a:t>
-            </a:r>
-            <a:r>
-              <a:rPr lang="en-US" sz="1000" dirty="0"/>
-              <a:t>-Munoz, “Marathon Performance Prediction of Amateur Runners based on Training Session Data.”</a:t>
-            </a:r>
-          </a:p>
-          <a:p>
-            <a:pPr marL="114300" indent="0" algn="just">
-              <a:buNone/>
-            </a:pPr>
-            <a:endParaRPr lang="en-US" sz="1000" dirty="0"/>
-          </a:p>
-          <a:p>
-            <a:pPr marL="114300" indent="0" algn="just">
-              <a:buNone/>
-            </a:pPr>
-            <a:r>
-              <a:rPr lang="en-US" sz="1000" dirty="0"/>
-              <a:t>[2] C. Feely, B. Caulfield, A. Lawlor, and B. Smyth, “Providing Explainable Race-Time Predictions and Training Plan Recommendations to Marathon Runners,” in Fourteenth ACM Conference on Recommender Systems. Virtual Event Brazil: ACM, Sep. 2020, pp. 539–544. [Online]. Available: </a:t>
-            </a:r>
-            <a:r>
-              <a:rPr lang="en-US" sz="1000" dirty="0">
-                <a:hlinkClick r:id="rId3"/>
-              </a:rPr>
-              <a:t>https://dl.acm.org/doi/10.1145/3383313.3412220</a:t>
-            </a:r>
-            <a:endParaRPr lang="en-US" sz="1000" dirty="0"/>
-          </a:p>
-          <a:p>
-            <a:pPr marL="114300" indent="0" algn="just">
-              <a:buNone/>
-            </a:pPr>
-            <a:endParaRPr lang="en-US" sz="1000" dirty="0"/>
-          </a:p>
-          <a:p>
-            <a:pPr marL="114300" indent="0" algn="just">
-              <a:buNone/>
-            </a:pPr>
-            <a:r>
-              <a:rPr lang="en-US" sz="1000" dirty="0"/>
-              <a:t>[3] </a:t>
-            </a:r>
-            <a:r>
-              <a:rPr lang="en-US" sz="1000" dirty="0" err="1"/>
-              <a:t>zuskakluska</a:t>
-            </a:r>
-            <a:r>
-              <a:rPr lang="en-US" sz="1000" dirty="0"/>
-              <a:t>, “Intelligent marathon race predictions,” https://www. kaggle.com/code/</a:t>
-            </a:r>
-            <a:r>
-              <a:rPr lang="en-US" sz="1000" dirty="0" err="1"/>
-              <a:t>zuskakluska</a:t>
-            </a:r>
-            <a:r>
-              <a:rPr lang="en-US" sz="1000" dirty="0"/>
-              <a:t>/intelligent-marathon-race-predictions, 2025, [Online; accessed 11-April-2026].</a:t>
-            </a:r>
-          </a:p>
-          <a:p>
-            <a:pPr marL="114300" indent="0" algn="just">
-              <a:buNone/>
-            </a:pPr>
-            <a:endParaRPr lang="en-US" sz="1000" dirty="0"/>
-          </a:p>
-          <a:p>
-            <a:pPr marL="114300" indent="0" algn="just">
-              <a:buNone/>
-            </a:pPr>
-            <a:r>
-              <a:rPr lang="en-US" sz="1000" dirty="0"/>
-              <a:t>[4] S. Dash, “Win Your Race Goal: A Generalized Approach to Prediction of Running Performance,” Sports Medicine International Open, vol. 08, no. CP, pp. a–2401–6234, Oct. 2024. [Online]. Available: </a:t>
-            </a:r>
-            <a:r>
-              <a:rPr lang="en-US" sz="1000" dirty="0">
-                <a:hlinkClick r:id="rId4"/>
-              </a:rPr>
-              <a:t>http://www.thieme-connect.de/DOI/DOI?10.1055/a-2401-6234</a:t>
-            </a:r>
-            <a:endParaRPr lang="en-US" sz="1000" dirty="0"/>
-          </a:p>
-          <a:p>
-            <a:pPr marL="114300" indent="0" algn="just">
-              <a:buNone/>
-            </a:pPr>
-            <a:endParaRPr lang="en-US" sz="1000" dirty="0"/>
-          </a:p>
-          <a:p>
-            <a:pPr marL="114300" indent="0" algn="just">
-              <a:buNone/>
-            </a:pPr>
-            <a:r>
-              <a:rPr lang="en-US" sz="1000" dirty="0"/>
-              <a:t>[5] L. Lerebourg, D. </a:t>
-            </a:r>
-            <a:r>
-              <a:rPr lang="en-US" sz="1000" dirty="0" err="1"/>
-              <a:t>Saboul</a:t>
-            </a:r>
-            <a:r>
-              <a:rPr lang="en-US" sz="1000" dirty="0"/>
-              <a:t>, M. </a:t>
-            </a:r>
-            <a:r>
-              <a:rPr lang="en-US" sz="1000" dirty="0" err="1"/>
-              <a:t>Cl´emenc¸on</a:t>
-            </a:r>
-            <a:r>
-              <a:rPr lang="en-US" sz="1000" dirty="0"/>
-              <a:t>, and J. B. </a:t>
-            </a:r>
-            <a:r>
-              <a:rPr lang="en-US" sz="1000" dirty="0" err="1"/>
-              <a:t>Coquart</a:t>
-            </a:r>
-            <a:r>
-              <a:rPr lang="en-US" sz="1000" dirty="0"/>
-              <a:t>, “Prediction of Marathon Performance using Artificial Intelligence,” International Journal of Sports Medicine, vol. 44, no. 05, pp. 352–360, May 2023. [Online]. Available: http://www.thieme-connect.de/DOI/DOI?10.1055/ a-1993-2371</a:t>
-            </a:r>
-          </a:p>
-          <a:p>
-            <a:pPr marL="114300" indent="0" algn="just">
-              <a:buNone/>
-            </a:pPr>
-            <a:endParaRPr lang="en-US" sz="1000" dirty="0"/>
-          </a:p>
-          <a:p>
-            <a:pPr marL="114300" indent="0" algn="just">
-              <a:buNone/>
-            </a:pPr>
-            <a:r>
-              <a:rPr lang="en-US" sz="1000" dirty="0"/>
-              <a:t>[6] H. T. El-Kassabi, K. Khalil, and M. A. </a:t>
-            </a:r>
-            <a:r>
-              <a:rPr lang="en-US" sz="1000" dirty="0" err="1"/>
-              <a:t>Serhani</a:t>
-            </a:r>
-            <a:r>
-              <a:rPr lang="en-US" sz="1000" dirty="0"/>
-              <a:t>, “Deep Learning Approach for Forecasting Athletes’ Performance in Sports Tournaments,” in Proceedings of the 13th International Conference on Intelligent Systems: Theories and Applications. Rabat Morocco: ACM, Sep. 2020, pp. 1–6. [Online]. Available: https://dl.acm.org/doi/10.1145/3419604.3419786</a:t>
-            </a:r>
-          </a:p>
-          <a:p>
-            <a:pPr marL="114300" indent="0">
-              <a:buNone/>
-            </a:pPr>
-            <a:endParaRPr lang="en-US" sz="1050" dirty="0"/>
-          </a:p>
-          <a:p>
-            <a:pPr marL="114300" indent="0">
-              <a:buNone/>
-            </a:pPr>
-            <a:endParaRPr lang="en-US" sz="1050" dirty="0"/>
-          </a:p>
-          <a:p>
-            <a:pPr marL="114300" indent="0">
-              <a:buNone/>
-            </a:pPr>
-            <a:endParaRPr lang="en-US" sz="1050" dirty="0"/>
-          </a:p>
-          <a:p>
-            <a:pPr lvl="1">
-              <a:spcBef>
-                <a:spcPts val="0"/>
-              </a:spcBef>
-            </a:pPr>
-            <a:endParaRPr lang="en-US" sz="800" dirty="0"/>
-          </a:p>
-          <a:p>
-            <a:pPr marL="596900" lvl="1" indent="0">
-              <a:spcBef>
-                <a:spcPts val="0"/>
-              </a:spcBef>
-              <a:buNone/>
-            </a:pPr>
-            <a:endParaRPr lang="en-US" sz="800" dirty="0"/>
-          </a:p>
-          <a:p>
-            <a:endParaRPr lang="en-US" sz="800" dirty="0"/>
-          </a:p>
-        </p:txBody>
-      </p:sp>
-    </p:spTree>
-    <p:extLst>
-      <p:ext uri="{BB962C8B-B14F-4D97-AF65-F5344CB8AC3E}">
-        <p14:creationId xmlns:p14="http://schemas.microsoft.com/office/powerpoint/2010/main" val="1793795348"/>
       </p:ext>
     </p:extLst>
   </p:cSld>
@@ -9127,6 +10178,15 @@
 </file>
 
 <file path=customXml/item1.xml><?xml version="1.0" encoding="utf-8"?>
+<?mso-contentType ?>
+<FormTemplates xmlns="http://schemas.microsoft.com/sharepoint/v3/contenttype/forms">
+  <Display>DocumentLibraryForm</Display>
+  <Edit>DocumentLibraryForm</Edit>
+  <New>DocumentLibraryForm</New>
+</FormTemplates>
+</file>
+
+<file path=customXml/item2.xml><?xml version="1.0" encoding="utf-8"?>
 <ct:contentTypeSchema xmlns:ct="http://schemas.microsoft.com/office/2006/metadata/contentType" xmlns:ma="http://schemas.microsoft.com/office/2006/metadata/properties/metaAttributes" ct:_="" ma:_="" ma:contentTypeName="Document" ma:contentTypeID="0x0101008B9C9BAE85AC824696340B84EAE46327" ma:contentTypeVersion="11" ma:contentTypeDescription="Create a new document." ma:contentTypeScope="" ma:versionID="91c83a4d36b47cc159eeda212718ddf0">
   <xsd:schema xmlns:xsd="http://www.w3.org/2001/XMLSchema" xmlns:xs="http://www.w3.org/2001/XMLSchema" xmlns:p="http://schemas.microsoft.com/office/2006/metadata/properties" xmlns:ns2="d17de636-3a20-4426-b1f0-60844d1a7157" xmlns:ns3="10616529-6cb0-43d7-b865-4daf29c215d1" targetNamespace="http://schemas.microsoft.com/office/2006/metadata/properties" ma:root="true" ma:fieldsID="13275efd5248ad822b5e77de4a07ba8d" ns2:_="" ns3:_="">
     <xsd:import namespace="d17de636-3a20-4426-b1f0-60844d1a7157"/>
@@ -9321,7 +10381,7 @@
 </ct:contentTypeSchema>
 </file>
 
-<file path=customXml/item2.xml><?xml version="1.0" encoding="utf-8"?>
+<file path=customXml/item3.xml><?xml version="1.0" encoding="utf-8"?>
 <p:properties xmlns:p="http://schemas.microsoft.com/office/2006/metadata/properties" xmlns:xsi="http://www.w3.org/2001/XMLSchema-instance" xmlns:pc="http://schemas.microsoft.com/office/infopath/2007/PartnerControls">
   <documentManagement>
     <lcf76f155ced4ddcb4097134ff3c332f xmlns="d17de636-3a20-4426-b1f0-60844d1a7157">
@@ -9332,16 +10392,15 @@
 </p:properties>
 </file>
 
-<file path=customXml/item3.xml><?xml version="1.0" encoding="utf-8"?>
-<?mso-contentType ?>
-<FormTemplates xmlns="http://schemas.microsoft.com/sharepoint/v3/contenttype/forms">
-  <Display>DocumentLibraryForm</Display>
-  <Edit>DocumentLibraryForm</Edit>
-  <New>DocumentLibraryForm</New>
-</FormTemplates>
+<file path=customXml/itemProps1.xml><?xml version="1.0" encoding="utf-8"?>
+<ds:datastoreItem xmlns:ds="http://schemas.openxmlformats.org/officeDocument/2006/customXml" ds:itemID="{78727EC3-027E-415E-8E65-39AD5268606C}">
+  <ds:schemaRefs>
+    <ds:schemaRef ds:uri="http://schemas.microsoft.com/sharepoint/v3/contenttype/forms"/>
+  </ds:schemaRefs>
+</ds:datastoreItem>
 </file>
 
-<file path=customXml/itemProps1.xml><?xml version="1.0" encoding="utf-8"?>
+<file path=customXml/itemProps2.xml><?xml version="1.0" encoding="utf-8"?>
 <ds:datastoreItem xmlns:ds="http://schemas.openxmlformats.org/officeDocument/2006/customXml" ds:itemID="{790FCD54-7BE1-4DF4-80C3-33338D52714A}">
   <ds:schemaRefs>
     <ds:schemaRef ds:uri="http://schemas.microsoft.com/office/2006/metadata/contentType"/>
@@ -9360,7 +10419,7 @@
 </ds:datastoreItem>
 </file>
 
-<file path=customXml/itemProps2.xml><?xml version="1.0" encoding="utf-8"?>
+<file path=customXml/itemProps3.xml><?xml version="1.0" encoding="utf-8"?>
 <ds:datastoreItem xmlns:ds="http://schemas.openxmlformats.org/officeDocument/2006/customXml" ds:itemID="{C3CE82D3-3DAB-415F-ABBA-4A99DAAF7228}">
   <ds:schemaRefs>
     <ds:schemaRef ds:uri="http://schemas.microsoft.com/office/2006/metadata/properties"/>
@@ -9369,12 +10428,4 @@
     <ds:schemaRef ds:uri="10616529-6cb0-43d7-b865-4daf29c215d1"/>
   </ds:schemaRefs>
 </ds:datastoreItem>
-</file>
-
-<file path=customXml/itemProps3.xml><?xml version="1.0" encoding="utf-8"?>
-<ds:datastoreItem xmlns:ds="http://schemas.openxmlformats.org/officeDocument/2006/customXml" ds:itemID="{78727EC3-027E-415E-8E65-39AD5268606C}">
-  <ds:schemaRefs>
-    <ds:schemaRef ds:uri="http://schemas.microsoft.com/sharepoint/v3/contenttype/forms"/>
-  </ds:schemaRefs>
-</ds:datastoreItem>
 </file>
</xml_diff>